<commit_message>
Docs TI: atualiza documentação técnica e decks com Farol Frota, Acessos e Recebe Farol
- DOCUMENTACAO-TI.md: nova seção Farol Frota (fontes, seções, envio por e-mail), painel Acessos + access_log, coluna farol_unidades, farol-mailer/workflow, diagrama e rotina atualizados
- docs/*.pptx: decks técnico (18 slides) e business (13) regenerados com Farol e Acessos

Co-Authored-By: Claude Opus 4.8 <noreply@anthropic.com>
Claude-Session: https://claude.ai/code/session_01CoPzrx19nUHZqody5fEJUg
</commit_message>
<xml_diff>
--- a/docs/Gestao-em-Movimento_Business.pptx
+++ b/docs/Gestao-em-Movimento_Business.pptx
@@ -17,6 +17,7 @@
     <p:sldId id="265" r:id="rId16"/>
     <p:sldId id="266" r:id="rId17"/>
     <p:sldId id="267" r:id="rId18"/>
+    <p:sldId id="268" r:id="rId19"/>
   </p:sldIdLst>
   <p:sldSz cx="12191695" cy="6858000" type="screen4x3"/>
   <p:notesSz cx="6858000" cy="9144000"/>
@@ -3426,21 +3427,381 @@
                 </a:solidFill>
                 <a:latin typeface="Montserrat"/>
               </a:rPr>
-              <a:t>Acesso e governança</a:t>
-            </a:r>
-          </a:p>
-        </p:txBody>
-      </p:sp>
-      <p:sp>
-        <p:nvSpPr>
-          <p:cNvPr id="5" name="TextBox 4"/>
+              <a:t>Benefícios</a:t>
+            </a:r>
+          </a:p>
+        </p:txBody>
+      </p:sp>
+      <p:sp>
+        <p:nvSpPr>
+          <p:cNvPr id="5" name="Rounded Rectangle 4"/>
+          <p:cNvSpPr/>
+          <p:nvPr/>
+        </p:nvSpPr>
+        <p:spPr>
+          <a:xfrm>
+            <a:off x="548640" y="1554480"/>
+            <a:ext cx="5394960" cy="1417320"/>
+          </a:xfrm>
+          <a:prstGeom prst="roundRect">
+            <a:avLst/>
+          </a:prstGeom>
+          <a:solidFill>
+            <a:srgbClr val="141B26"/>
+          </a:solidFill>
+          <a:ln w="12700">
+            <a:solidFill>
+              <a:srgbClr val="1E2D40"/>
+            </a:solidFill>
+          </a:ln>
+        </p:spPr>
+        <p:style>
+          <a:lnRef idx="1">
+            <a:schemeClr val="accent1"/>
+          </a:lnRef>
+          <a:fillRef idx="3">
+            <a:schemeClr val="accent1"/>
+          </a:fillRef>
+          <a:effectRef idx="2">
+            <a:schemeClr val="accent1"/>
+          </a:effectRef>
+          <a:fontRef idx="minor">
+            <a:schemeClr val="lt1"/>
+          </a:fontRef>
+        </p:style>
+        <p:txBody>
+          <a:bodyPr rtlCol="0" anchor="t" wrap="square" lIns="146304" rIns="128016" tIns="91440" bIns="73152"/>
+          <a:lstStyle/>
+          <a:p>
+            <a:pPr algn="ctr">
+              <a:spcAft>
+                <a:spcPts val="400"/>
+              </a:spcAft>
+            </a:pPr>
+            <a:r>
+              <a:rPr sz="1300" b="1" i="0">
+                <a:solidFill>
+                  <a:srgbClr val="3BB33B"/>
+                </a:solidFill>
+                <a:latin typeface="Montserrat"/>
+              </a:rPr>
+              <a:t>CUSTO ≈ ZERO DE INFRAESTRUTURA</a:t>
+            </a:r>
+          </a:p>
+          <a:p>
+            <a:pPr>
+              <a:spcAft>
+                <a:spcPts val="200"/>
+              </a:spcAft>
+            </a:pPr>
+            <a:r>
+              <a:rPr sz="1100" b="0" i="0">
+                <a:solidFill>
+                  <a:srgbClr val="94A3B8"/>
+                </a:solidFill>
+                <a:latin typeface="Montserrat"/>
+              </a:rPr>
+              <a:t>Hospedagem e automações em camadas gratuitas;</a:t>
+            </a:r>
+          </a:p>
+          <a:p>
+            <a:pPr>
+              <a:spcAft>
+                <a:spcPts val="200"/>
+              </a:spcAft>
+            </a:pPr>
+            <a:r>
+              <a:rPr sz="1100" b="0" i="0">
+                <a:solidFill>
+                  <a:srgbClr val="94A3B8"/>
+                </a:solidFill>
+                <a:latin typeface="Montserrat"/>
+              </a:rPr>
+              <a:t>sem licença por usuário (vs. ferramenta paga de BI)</a:t>
+            </a:r>
+          </a:p>
+        </p:txBody>
+      </p:sp>
+      <p:sp>
+        <p:nvSpPr>
+          <p:cNvPr id="6" name="Rounded Rectangle 5"/>
+          <p:cNvSpPr/>
+          <p:nvPr/>
+        </p:nvSpPr>
+        <p:spPr>
+          <a:xfrm>
+            <a:off x="6217920" y="1554480"/>
+            <a:ext cx="5394960" cy="1417320"/>
+          </a:xfrm>
+          <a:prstGeom prst="roundRect">
+            <a:avLst/>
+          </a:prstGeom>
+          <a:solidFill>
+            <a:srgbClr val="141B26"/>
+          </a:solidFill>
+          <a:ln w="12700">
+            <a:solidFill>
+              <a:srgbClr val="1E2D40"/>
+            </a:solidFill>
+          </a:ln>
+        </p:spPr>
+        <p:style>
+          <a:lnRef idx="1">
+            <a:schemeClr val="accent1"/>
+          </a:lnRef>
+          <a:fillRef idx="3">
+            <a:schemeClr val="accent1"/>
+          </a:fillRef>
+          <a:effectRef idx="2">
+            <a:schemeClr val="accent1"/>
+          </a:effectRef>
+          <a:fontRef idx="minor">
+            <a:schemeClr val="lt1"/>
+          </a:fontRef>
+        </p:style>
+        <p:txBody>
+          <a:bodyPr rtlCol="0" anchor="t" wrap="square" lIns="146304" rIns="128016" tIns="91440" bIns="73152"/>
+          <a:lstStyle/>
+          <a:p>
+            <a:pPr algn="ctr">
+              <a:spcAft>
+                <a:spcPts val="400"/>
+              </a:spcAft>
+            </a:pPr>
+            <a:r>
+              <a:rPr sz="1300" b="1" i="0">
+                <a:solidFill>
+                  <a:srgbClr val="3BB33B"/>
+                </a:solidFill>
+                <a:latin typeface="Montserrat"/>
+              </a:rPr>
+              <a:t>FONTE ÚNICA DA VERDADE</a:t>
+            </a:r>
+          </a:p>
+          <a:p>
+            <a:pPr>
+              <a:spcAft>
+                <a:spcPts val="200"/>
+              </a:spcAft>
+            </a:pPr>
+            <a:r>
+              <a:rPr sz="1100" b="0" i="0">
+                <a:solidFill>
+                  <a:srgbClr val="94A3B8"/>
+                </a:solidFill>
+                <a:latin typeface="Montserrat"/>
+              </a:rPr>
+              <a:t>Mesmo número em todos os painéis;</a:t>
+            </a:r>
+          </a:p>
+          <a:p>
+            <a:pPr>
+              <a:spcAft>
+                <a:spcPts val="200"/>
+              </a:spcAft>
+            </a:pPr>
+            <a:r>
+              <a:rPr sz="1100" b="0" i="0">
+                <a:solidFill>
+                  <a:srgbClr val="94A3B8"/>
+                </a:solidFill>
+                <a:latin typeface="Montserrat"/>
+              </a:rPr>
+              <a:t>planos de ação centralizados e auditáveis na nuvem</a:t>
+            </a:r>
+          </a:p>
+        </p:txBody>
+      </p:sp>
+      <p:sp>
+        <p:nvSpPr>
+          <p:cNvPr id="7" name="Rounded Rectangle 6"/>
+          <p:cNvSpPr/>
+          <p:nvPr/>
+        </p:nvSpPr>
+        <p:spPr>
+          <a:xfrm>
+            <a:off x="548640" y="3154680"/>
+            <a:ext cx="5394960" cy="1417320"/>
+          </a:xfrm>
+          <a:prstGeom prst="roundRect">
+            <a:avLst/>
+          </a:prstGeom>
+          <a:solidFill>
+            <a:srgbClr val="141B26"/>
+          </a:solidFill>
+          <a:ln w="12700">
+            <a:solidFill>
+              <a:srgbClr val="1E2D40"/>
+            </a:solidFill>
+          </a:ln>
+        </p:spPr>
+        <p:style>
+          <a:lnRef idx="1">
+            <a:schemeClr val="accent1"/>
+          </a:lnRef>
+          <a:fillRef idx="3">
+            <a:schemeClr val="accent1"/>
+          </a:fillRef>
+          <a:effectRef idx="2">
+            <a:schemeClr val="accent1"/>
+          </a:effectRef>
+          <a:fontRef idx="minor">
+            <a:schemeClr val="lt1"/>
+          </a:fontRef>
+        </p:style>
+        <p:txBody>
+          <a:bodyPr rtlCol="0" anchor="t" wrap="square" lIns="146304" rIns="128016" tIns="91440" bIns="73152"/>
+          <a:lstStyle/>
+          <a:p>
+            <a:pPr algn="ctr">
+              <a:spcAft>
+                <a:spcPts val="400"/>
+              </a:spcAft>
+            </a:pPr>
+            <a:r>
+              <a:rPr sz="1300" b="1" i="0">
+                <a:solidFill>
+                  <a:srgbClr val="3BB33B"/>
+                </a:solidFill>
+                <a:latin typeface="Montserrat"/>
+              </a:rPr>
+              <a:t>GOVERNANÇA E ACCOUNTABILITY</a:t>
+            </a:r>
+          </a:p>
+          <a:p>
+            <a:pPr>
+              <a:spcAft>
+                <a:spcPts val="200"/>
+              </a:spcAft>
+            </a:pPr>
+            <a:r>
+              <a:rPr sz="1100" b="0" i="0">
+                <a:solidFill>
+                  <a:srgbClr val="94A3B8"/>
+                </a:solidFill>
+                <a:latin typeface="Montserrat"/>
+              </a:rPr>
+              <a:t>Cada desvio com dono, prazo e status;</a:t>
+            </a:r>
+          </a:p>
+          <a:p>
+            <a:pPr>
+              <a:spcAft>
+                <a:spcPts val="200"/>
+              </a:spcAft>
+            </a:pPr>
+            <a:r>
+              <a:rPr sz="1100" b="0" i="0">
+                <a:solidFill>
+                  <a:srgbClr val="94A3B8"/>
+                </a:solidFill>
+                <a:latin typeface="Montserrat"/>
+              </a:rPr>
+              <a:t>aderência medida; ranking dá consequência</a:t>
+            </a:r>
+          </a:p>
+        </p:txBody>
+      </p:sp>
+      <p:sp>
+        <p:nvSpPr>
+          <p:cNvPr id="8" name="Rounded Rectangle 7"/>
+          <p:cNvSpPr/>
+          <p:nvPr/>
+        </p:nvSpPr>
+        <p:spPr>
+          <a:xfrm>
+            <a:off x="6217920" y="3154680"/>
+            <a:ext cx="5394960" cy="1417320"/>
+          </a:xfrm>
+          <a:prstGeom prst="roundRect">
+            <a:avLst/>
+          </a:prstGeom>
+          <a:solidFill>
+            <a:srgbClr val="141B26"/>
+          </a:solidFill>
+          <a:ln w="12700">
+            <a:solidFill>
+              <a:srgbClr val="1E2D40"/>
+            </a:solidFill>
+          </a:ln>
+        </p:spPr>
+        <p:style>
+          <a:lnRef idx="1">
+            <a:schemeClr val="accent1"/>
+          </a:lnRef>
+          <a:fillRef idx="3">
+            <a:schemeClr val="accent1"/>
+          </a:fillRef>
+          <a:effectRef idx="2">
+            <a:schemeClr val="accent1"/>
+          </a:effectRef>
+          <a:fontRef idx="minor">
+            <a:schemeClr val="lt1"/>
+          </a:fontRef>
+        </p:style>
+        <p:txBody>
+          <a:bodyPr rtlCol="0" anchor="t" wrap="square" lIns="146304" rIns="128016" tIns="91440" bIns="73152"/>
+          <a:lstStyle/>
+          <a:p>
+            <a:pPr algn="ctr">
+              <a:spcAft>
+                <a:spcPts val="400"/>
+              </a:spcAft>
+            </a:pPr>
+            <a:r>
+              <a:rPr sz="1300" b="1" i="0">
+                <a:solidFill>
+                  <a:srgbClr val="3BB33B"/>
+                </a:solidFill>
+                <a:latin typeface="Montserrat"/>
+              </a:rPr>
+              <a:t>AGILIDADE</a:t>
+            </a:r>
+          </a:p>
+          <a:p>
+            <a:pPr>
+              <a:spcAft>
+                <a:spcPts val="200"/>
+              </a:spcAft>
+            </a:pPr>
+            <a:r>
+              <a:rPr sz="1100" b="0" i="0">
+                <a:solidFill>
+                  <a:srgbClr val="94A3B8"/>
+                </a:solidFill>
+                <a:latin typeface="Montserrat"/>
+              </a:rPr>
+              <a:t>Dados ao abrir a página (sem espera de carga);</a:t>
+            </a:r>
+          </a:p>
+          <a:p>
+            <a:pPr>
+              <a:spcAft>
+                <a:spcPts val="200"/>
+              </a:spcAft>
+            </a:pPr>
+            <a:r>
+              <a:rPr sz="1100" b="0" i="0">
+                <a:solidFill>
+                  <a:srgbClr val="94A3B8"/>
+                </a:solidFill>
+                <a:latin typeface="Montserrat"/>
+              </a:rPr>
+              <a:t>novos painéis em dias, sem depender de fornecedor</a:t>
+            </a:r>
+          </a:p>
+        </p:txBody>
+      </p:sp>
+      <p:sp>
+        <p:nvSpPr>
+          <p:cNvPr id="9" name="TextBox 8"/>
           <p:cNvSpPr txBox="1"/>
           <p:nvPr/>
         </p:nvSpPr>
         <p:spPr>
           <a:xfrm>
-            <a:off x="548640" y="1417320"/>
-            <a:ext cx="11064240" cy="5120640"/>
+            <a:off x="548640" y="4892040"/>
+            <a:ext cx="11064240" cy="1097280"/>
           </a:xfrm>
           <a:prstGeom prst="rect">
             <a:avLst/>
@@ -3453,135 +3814,21 @@
           </a:bodyPr>
           <a:lstStyle/>
           <a:p>
-            <a:pPr>
-              <a:spcAft>
-                <a:spcPts val="700"/>
-              </a:spcAft>
-            </a:pPr>
-            <a:r>
-              <a:rPr sz="1600" b="1" i="0">
+            <a:r>
+              <a:rPr sz="1400" b="1" i="0">
                 <a:solidFill>
                   <a:srgbClr val="F97316"/>
                 </a:solidFill>
                 <a:latin typeface="Montserrat"/>
               </a:rPr>
-              <a:t>▪  </a:t>
-            </a:r>
-            <a:r>
-              <a:rPr sz="1600" b="0" i="0">
-                <a:solidFill>
-                  <a:srgbClr val="F1F5F9"/>
-                </a:solidFill>
-                <a:latin typeface="Montserrat"/>
-              </a:rPr>
-              <a:t>Login individual (e-mail corporativo) com confirmação; recuperação de senha automática.</a:t>
-            </a:r>
-          </a:p>
-          <a:p>
-            <a:pPr>
-              <a:spcAft>
-                <a:spcPts val="700"/>
-              </a:spcAft>
-            </a:pPr>
-            <a:r>
-              <a:rPr sz="1600" b="1" i="0">
-                <a:solidFill>
-                  <a:srgbClr val="F97316"/>
-                </a:solidFill>
-                <a:latin typeface="Montserrat"/>
-              </a:rPr>
-              <a:t>▪  </a:t>
-            </a:r>
-            <a:r>
-              <a:rPr sz="1600" b="0" i="0">
-                <a:solidFill>
-                  <a:srgbClr val="F1F5F9"/>
-                </a:solidFill>
-                <a:latin typeface="Montserrat"/>
-              </a:rPr>
-              <a:t>Perfil por unidade: o gestor de CGR só enxerga e edita CGR; admin enxerga tudo.</a:t>
-            </a:r>
-          </a:p>
-          <a:p>
-            <a:pPr>
-              <a:spcAft>
-                <a:spcPts val="700"/>
-              </a:spcAft>
-            </a:pPr>
-            <a:r>
-              <a:rPr sz="1600" b="1" i="0">
-                <a:solidFill>
-                  <a:srgbClr val="F97316"/>
-                </a:solidFill>
-                <a:latin typeface="Montserrat"/>
-              </a:rPr>
-              <a:t>▪  </a:t>
-            </a:r>
-            <a:r>
-              <a:rPr sz="1600" b="0" i="0">
-                <a:solidFill>
-                  <a:srgbClr val="F1F5F9"/>
-                </a:solidFill>
-                <a:latin typeface="Montserrat"/>
-              </a:rPr>
-              <a:t>Aprovação de novos usuários centralizada no card “Gerenciar Acessos” (admin).</a:t>
-            </a:r>
-          </a:p>
-          <a:p>
-            <a:pPr>
-              <a:spcAft>
-                <a:spcPts val="700"/>
-              </a:spcAft>
-            </a:pPr>
-            <a:r>
-              <a:rPr sz="1600" b="1" i="0">
-                <a:solidFill>
-                  <a:srgbClr val="F97316"/>
-                </a:solidFill>
-                <a:latin typeface="Montserrat"/>
-              </a:rPr>
-              <a:t>▪  </a:t>
-            </a:r>
-            <a:r>
-              <a:rPr sz="1600" b="0" i="0">
-                <a:solidFill>
-                  <a:srgbClr val="F1F5F9"/>
-                </a:solidFill>
-                <a:latin typeface="Montserrat"/>
-              </a:rPr>
-              <a:t>Ações do FCA travadas após salvar — histórico não pode ser reescrito (só acompanhamento evolui).</a:t>
-            </a:r>
-          </a:p>
-          <a:p>
-            <a:pPr>
-              <a:spcAft>
-                <a:spcPts val="700"/>
-              </a:spcAft>
-            </a:pPr>
-            <a:r>
-              <a:rPr sz="1600" b="1" i="0">
-                <a:solidFill>
-                  <a:srgbClr val="F97316"/>
-                </a:solidFill>
-                <a:latin typeface="Montserrat"/>
-              </a:rPr>
-              <a:t>▪  </a:t>
-            </a:r>
-            <a:r>
-              <a:rPr sz="1600" b="0" i="0">
-                <a:solidFill>
-                  <a:srgbClr val="F1F5F9"/>
-                </a:solidFill>
-                <a:latin typeface="Montserrat"/>
-              </a:rPr>
-              <a:t>Todo o código versionado (GitHub) — cada mudança tem autor, data e histórico completo.</a:t>
-            </a:r>
-          </a:p>
-        </p:txBody>
-      </p:sp>
-      <p:sp>
-        <p:nvSpPr>
-          <p:cNvPr id="6" name="TextBox 5"/>
+              <a:t>Substituição completa do Looker Studio concluída — com mais funcionalidades (preenchimento, kanban, travas, perfis).</a:t>
+            </a:r>
+          </a:p>
+        </p:txBody>
+      </p:sp>
+      <p:sp>
+        <p:nvSpPr>
+          <p:cNvPr id="10" name="TextBox 9"/>
           <p:cNvSpPr txBox="1"/>
           <p:nvPr/>
         </p:nvSpPr>
@@ -3766,7 +4013,7 @@
                 </a:solidFill>
                 <a:latin typeface="Montserrat"/>
               </a:rPr>
-              <a:t>Roadmap sugerido</a:t>
+              <a:t>Acesso e governança</a:t>
             </a:r>
           </a:p>
         </p:txBody>
@@ -3799,7 +4046,7 @@
               </a:spcAft>
             </a:pPr>
             <a:r>
-              <a:rPr sz="1500" b="1" i="0">
+              <a:rPr sz="1600" b="1" i="0">
                 <a:solidFill>
                   <a:srgbClr val="F97316"/>
                 </a:solidFill>
@@ -3808,238 +4055,113 @@
               <a:t>▪  </a:t>
             </a:r>
             <a:r>
-              <a:rPr sz="1500" b="1" i="0">
+              <a:rPr sz="1600" b="0" i="0">
+                <a:solidFill>
+                  <a:srgbClr val="F1F5F9"/>
+                </a:solidFill>
+                <a:latin typeface="Montserrat"/>
+              </a:rPr>
+              <a:t>Login individual (e-mail corporativo) com confirmação; recuperação de senha automática.</a:t>
+            </a:r>
+          </a:p>
+          <a:p>
+            <a:pPr>
+              <a:spcAft>
+                <a:spcPts val="700"/>
+              </a:spcAft>
+            </a:pPr>
+            <a:r>
+              <a:rPr sz="1600" b="1" i="0">
                 <a:solidFill>
                   <a:srgbClr val="F97316"/>
                 </a:solidFill>
                 <a:latin typeface="Montserrat"/>
               </a:rPr>
-              <a:t>Curto prazo:</a:t>
+              <a:t>▪  </a:t>
+            </a:r>
+            <a:r>
+              <a:rPr sz="1600" b="0" i="0">
+                <a:solidFill>
+                  <a:srgbClr val="F1F5F9"/>
+                </a:solidFill>
+                <a:latin typeface="Montserrat"/>
+              </a:rPr>
+              <a:t>Perfil por unidade: o gestor de CGR só enxerga e edita CGR; admin enxerga tudo.</a:t>
             </a:r>
           </a:p>
           <a:p>
             <a:pPr>
               <a:spcAft>
-                <a:spcPts val="400"/>
-              </a:spcAft>
-            </a:pPr>
-            <a:r>
-              <a:rPr sz="1350" b="1" i="0">
-                <a:solidFill>
-                  <a:srgbClr val="64748B"/>
-                </a:solidFill>
-                <a:latin typeface="Montserrat"/>
-              </a:rPr>
-              <a:t>      –  </a:t>
-            </a:r>
-            <a:r>
-              <a:rPr sz="1350" b="0" i="0">
+                <a:spcPts val="700"/>
+              </a:spcAft>
+            </a:pPr>
+            <a:r>
+              <a:rPr sz="1600" b="1" i="0">
+                <a:solidFill>
+                  <a:srgbClr val="F97316"/>
+                </a:solidFill>
+                <a:latin typeface="Montserrat"/>
+              </a:rPr>
+              <a:t>▪  </a:t>
+            </a:r>
+            <a:r>
+              <a:rPr sz="1600" b="0" i="0">
                 <a:solidFill>
                   <a:srgbClr val="F1F5F9"/>
                 </a:solidFill>
                 <a:latin typeface="Montserrat"/>
               </a:rPr>
-              <a:t>Mover os campos do MPR para a nuvem (hoje ficam no navegador de quem digita)</a:t>
+              <a:t>Aprovação de novos usuários centralizada no card “Gerenciar Acessos” (admin).</a:t>
             </a:r>
           </a:p>
           <a:p>
             <a:pPr>
               <a:spcAft>
-                <a:spcPts val="400"/>
-              </a:spcAft>
-            </a:pPr>
-            <a:r>
-              <a:rPr sz="1350" b="1" i="0">
-                <a:solidFill>
-                  <a:srgbClr val="64748B"/>
-                </a:solidFill>
-                <a:latin typeface="Montserrat"/>
-              </a:rPr>
-              <a:t>      –  </a:t>
-            </a:r>
-            <a:r>
-              <a:rPr sz="1350" b="0" i="0">
+                <a:spcPts val="700"/>
+              </a:spcAft>
+            </a:pPr>
+            <a:r>
+              <a:rPr sz="1600" b="1" i="0">
+                <a:solidFill>
+                  <a:srgbClr val="F97316"/>
+                </a:solidFill>
+                <a:latin typeface="Montserrat"/>
+              </a:rPr>
+              <a:t>▪  </a:t>
+            </a:r>
+            <a:r>
+              <a:rPr sz="1600" b="0" i="0">
                 <a:solidFill>
                   <a:srgbClr val="F1F5F9"/>
                 </a:solidFill>
                 <a:latin typeface="Montserrat"/>
               </a:rPr>
-              <a:t>Aviso de “alterações não salvas” no FCA Preenchimento</a:t>
+              <a:t>Ações do FCA travadas após salvar — histórico não pode ser reescrito (só acompanhamento evolui).</a:t>
             </a:r>
           </a:p>
           <a:p>
             <a:pPr>
               <a:spcAft>
-                <a:spcPts val="400"/>
-              </a:spcAft>
-            </a:pPr>
-            <a:r>
-              <a:rPr sz="1350" b="1" i="0">
-                <a:solidFill>
-                  <a:srgbClr val="64748B"/>
-                </a:solidFill>
-                <a:latin typeface="Montserrat"/>
-              </a:rPr>
-              <a:t>      –  </a:t>
-            </a:r>
-            <a:r>
-              <a:rPr sz="1350" b="0" i="0">
+                <a:spcPts val="700"/>
+              </a:spcAft>
+            </a:pPr>
+            <a:r>
+              <a:rPr sz="1600" b="1" i="0">
+                <a:solidFill>
+                  <a:srgbClr val="F97316"/>
+                </a:solidFill>
+                <a:latin typeface="Montserrat"/>
+              </a:rPr>
+              <a:t>▪  </a:t>
+            </a:r>
+            <a:r>
+              <a:rPr sz="1600" b="0" i="0">
                 <a:solidFill>
                   <a:srgbClr val="F1F5F9"/>
                 </a:solidFill>
                 <a:latin typeface="Montserrat"/>
               </a:rPr>
-              <a:t>Rotação de credencial pendente (integração Conlog) — higiene de segurança</a:t>
-            </a:r>
-          </a:p>
-          <a:p>
-            <a:pPr>
-              <a:spcAft>
-                <a:spcPts val="700"/>
-              </a:spcAft>
-            </a:pPr>
-            <a:r>
-              <a:rPr sz="1500" b="1" i="0">
-                <a:solidFill>
-                  <a:srgbClr val="F97316"/>
-                </a:solidFill>
-                <a:latin typeface="Montserrat"/>
-              </a:rPr>
-              <a:t>▪  </a:t>
-            </a:r>
-            <a:r>
-              <a:rPr sz="1500" b="1" i="0">
-                <a:solidFill>
-                  <a:srgbClr val="F97316"/>
-                </a:solidFill>
-                <a:latin typeface="Montserrat"/>
-              </a:rPr>
-              <a:t>Médio prazo:</a:t>
-            </a:r>
-          </a:p>
-          <a:p>
-            <a:pPr>
-              <a:spcAft>
-                <a:spcPts val="400"/>
-              </a:spcAft>
-            </a:pPr>
-            <a:r>
-              <a:rPr sz="1350" b="1" i="0">
-                <a:solidFill>
-                  <a:srgbClr val="64748B"/>
-                </a:solidFill>
-                <a:latin typeface="Montserrat"/>
-              </a:rPr>
-              <a:t>      –  </a:t>
-            </a:r>
-            <a:r>
-              <a:rPr sz="1350" b="0" i="0">
-                <a:solidFill>
-                  <a:srgbClr val="F1F5F9"/>
-                </a:solidFill>
-                <a:latin typeface="Montserrat"/>
-              </a:rPr>
-              <a:t>Notificações (e-mail/WhatsApp) de prazo de ação vencendo</a:t>
-            </a:r>
-          </a:p>
-          <a:p>
-            <a:pPr>
-              <a:spcAft>
-                <a:spcPts val="400"/>
-              </a:spcAft>
-            </a:pPr>
-            <a:r>
-              <a:rPr sz="1350" b="1" i="0">
-                <a:solidFill>
-                  <a:srgbClr val="64748B"/>
-                </a:solidFill>
-                <a:latin typeface="Montserrat"/>
-              </a:rPr>
-              <a:t>      –  </a:t>
-            </a:r>
-            <a:r>
-              <a:rPr sz="1350" b="0" i="0">
-                <a:solidFill>
-                  <a:srgbClr val="F1F5F9"/>
-                </a:solidFill>
-                <a:latin typeface="Montserrat"/>
-              </a:rPr>
-              <a:t>Completar painéis “Em breve” (R$/KM avançado, sub-hubs de clusters)</a:t>
-            </a:r>
-          </a:p>
-          <a:p>
-            <a:pPr>
-              <a:spcAft>
-                <a:spcPts val="400"/>
-              </a:spcAft>
-            </a:pPr>
-            <a:r>
-              <a:rPr sz="1350" b="1" i="0">
-                <a:solidFill>
-                  <a:srgbClr val="64748B"/>
-                </a:solidFill>
-                <a:latin typeface="Montserrat"/>
-              </a:rPr>
-              <a:t>      –  </a:t>
-            </a:r>
-            <a:r>
-              <a:rPr sz="1350" b="0" i="0">
-                <a:solidFill>
-                  <a:srgbClr val="F1F5F9"/>
-                </a:solidFill>
-                <a:latin typeface="Montserrat"/>
-              </a:rPr>
-              <a:t>Trilha de auditoria de edições do FCA (quem alterou o quê)</a:t>
-            </a:r>
-          </a:p>
-          <a:p>
-            <a:pPr>
-              <a:spcAft>
-                <a:spcPts val="700"/>
-              </a:spcAft>
-            </a:pPr>
-            <a:r>
-              <a:rPr sz="1500" b="1" i="0">
-                <a:solidFill>
-                  <a:srgbClr val="F97316"/>
-                </a:solidFill>
-                <a:latin typeface="Montserrat"/>
-              </a:rPr>
-              <a:t>▪  </a:t>
-            </a:r>
-            <a:r>
-              <a:rPr sz="1500" b="1" i="0">
-                <a:solidFill>
-                  <a:srgbClr val="F97316"/>
-                </a:solidFill>
-                <a:latin typeface="Montserrat"/>
-              </a:rPr>
-              <a:t>Contínuo:</a:t>
-            </a:r>
-          </a:p>
-          <a:p>
-            <a:pPr>
-              <a:spcAft>
-                <a:spcPts val="400"/>
-              </a:spcAft>
-            </a:pPr>
-            <a:r>
-              <a:rPr sz="1350" b="1" i="0">
-                <a:solidFill>
-                  <a:srgbClr val="64748B"/>
-                </a:solidFill>
-                <a:latin typeface="Montserrat"/>
-              </a:rPr>
-              <a:t>      –  </a:t>
-            </a:r>
-            <a:r>
-              <a:rPr sz="1350" b="0" i="0">
-                <a:solidFill>
-                  <a:srgbClr val="F1F5F9"/>
-                </a:solidFill>
-                <a:latin typeface="Montserrat"/>
-              </a:rPr>
-              <a:t>Absorção da manutenção pela TI com base na documentação técnica (DOCUMENTACAO-TI.md + deck técnico)</a:t>
+              <a:t>Todo o código versionado (GitHub) — cada mudança tem autor, data e histórico completo.</a:t>
             </a:r>
           </a:p>
         </p:txBody>
@@ -4113,8 +4235,51 @@
         </p:nvSpPr>
         <p:spPr>
           <a:xfrm>
-            <a:off x="548640" y="3200400"/>
-            <a:ext cx="2377440" cy="38100"/>
+            <a:off x="0" y="0"/>
+            <a:ext cx="12191695" cy="1170432"/>
+          </a:xfrm>
+          <a:prstGeom prst="rect">
+            <a:avLst/>
+          </a:prstGeom>
+          <a:solidFill>
+            <a:srgbClr val="141B26"/>
+          </a:solidFill>
+          <a:ln>
+            <a:noFill/>
+          </a:ln>
+        </p:spPr>
+        <p:style>
+          <a:lnRef idx="1">
+            <a:schemeClr val="accent1"/>
+          </a:lnRef>
+          <a:fillRef idx="3">
+            <a:schemeClr val="accent1"/>
+          </a:fillRef>
+          <a:effectRef idx="2">
+            <a:schemeClr val="accent1"/>
+          </a:effectRef>
+          <a:fontRef idx="minor">
+            <a:schemeClr val="lt1"/>
+          </a:fontRef>
+        </p:style>
+        <p:txBody>
+          <a:bodyPr rtlCol="0" anchor="ctr"/>
+          <a:lstStyle/>
+          <a:p>
+            <a:pPr algn="ctr"/>
+          </a:p>
+        </p:txBody>
+      </p:sp>
+      <p:sp>
+        <p:nvSpPr>
+          <p:cNvPr id="3" name="Rectangle 2"/>
+          <p:cNvSpPr/>
+          <p:nvPr/>
+        </p:nvSpPr>
+        <p:spPr>
+          <a:xfrm>
+            <a:off x="0" y="1170432"/>
+            <a:ext cx="12191695" cy="27940"/>
           </a:xfrm>
           <a:prstGeom prst="rect">
             <a:avLst/>
@@ -4150,14 +4315,14 @@
       </p:sp>
       <p:sp>
         <p:nvSpPr>
-          <p:cNvPr id="3" name="TextBox 2"/>
+          <p:cNvPr id="4" name="TextBox 3"/>
           <p:cNvSpPr txBox="1"/>
           <p:nvPr/>
         </p:nvSpPr>
         <p:spPr>
           <a:xfrm>
-            <a:off x="548640" y="2011680"/>
-            <a:ext cx="10972800" cy="1188720"/>
+            <a:off x="548640" y="109728"/>
+            <a:ext cx="11064240" cy="1005840"/>
           </a:xfrm>
           <a:prstGeom prst="rect">
             <a:avLst/>
@@ -4171,27 +4336,38 @@
           <a:lstStyle/>
           <a:p>
             <a:r>
-              <a:rPr sz="4000" b="1" i="0">
-                <a:solidFill>
-                  <a:srgbClr val="F1F5F9"/>
-                </a:solidFill>
-                <a:latin typeface="Montserrat"/>
-              </a:rPr>
-              <a:t>Gestão em Movimento</a:t>
-            </a:r>
-          </a:p>
-        </p:txBody>
-      </p:sp>
-      <p:sp>
-        <p:nvSpPr>
-          <p:cNvPr id="4" name="TextBox 3"/>
+              <a:rPr sz="1000" b="1" i="0">
+                <a:solidFill>
+                  <a:srgbClr val="64748B"/>
+                </a:solidFill>
+                <a:latin typeface="Montserrat"/>
+              </a:rPr>
+              <a:t>GESTÃO EM MOVIMENTO · BI FROTA</a:t>
+            </a:r>
+          </a:p>
+          <a:p>
+            <a:r>
+              <a:rPr sz="2600" b="1" i="0">
+                <a:solidFill>
+                  <a:srgbClr val="F97316"/>
+                </a:solidFill>
+                <a:latin typeface="Montserrat"/>
+              </a:rPr>
+              <a:t>Roadmap sugerido</a:t>
+            </a:r>
+          </a:p>
+        </p:txBody>
+      </p:sp>
+      <p:sp>
+        <p:nvSpPr>
+          <p:cNvPr id="5" name="TextBox 4"/>
           <p:cNvSpPr txBox="1"/>
           <p:nvPr/>
         </p:nvSpPr>
         <p:spPr>
           <a:xfrm>
-            <a:off x="548640" y="3429000"/>
-            <a:ext cx="10972800" cy="2011680"/>
+            <a:off x="548640" y="1417320"/>
+            <a:ext cx="11064240" cy="5120640"/>
           </a:xfrm>
           <a:prstGeom prst="rect">
             <a:avLst/>
@@ -4204,32 +4380,260 @@
           </a:bodyPr>
           <a:lstStyle/>
           <a:p>
-            <a:r>
-              <a:rPr sz="1800" b="0" i="0">
-                <a:solidFill>
-                  <a:srgbClr val="94A3B8"/>
-                </a:solidFill>
-                <a:latin typeface="Montserrat"/>
-              </a:rPr>
-              <a:t>Do indicador à ação — a gestão da frota inteira num só lugar.</a:t>
-            </a:r>
-          </a:p>
-          <a:p>
-            <a:r>
-              <a:rPr sz="1400" b="1" i="0">
+            <a:pPr>
+              <a:spcAft>
+                <a:spcPts val="700"/>
+              </a:spcAft>
+            </a:pPr>
+            <a:r>
+              <a:rPr sz="1500" b="1" i="0">
                 <a:solidFill>
                   <a:srgbClr val="F97316"/>
                 </a:solidFill>
                 <a:latin typeface="Montserrat"/>
               </a:rPr>
-              <a:t>fortesindicadores-byte.github.io/gestao-em-movimento</a:t>
-            </a:r>
-          </a:p>
-        </p:txBody>
-      </p:sp>
-      <p:sp>
-        <p:nvSpPr>
-          <p:cNvPr id="5" name="TextBox 4"/>
+              <a:t>▪  </a:t>
+            </a:r>
+            <a:r>
+              <a:rPr sz="1500" b="1" i="0">
+                <a:solidFill>
+                  <a:srgbClr val="F97316"/>
+                </a:solidFill>
+                <a:latin typeface="Montserrat"/>
+              </a:rPr>
+              <a:t>Curto prazo:</a:t>
+            </a:r>
+          </a:p>
+          <a:p>
+            <a:pPr>
+              <a:spcAft>
+                <a:spcPts val="400"/>
+              </a:spcAft>
+            </a:pPr>
+            <a:r>
+              <a:rPr sz="1350" b="1" i="0">
+                <a:solidFill>
+                  <a:srgbClr val="64748B"/>
+                </a:solidFill>
+                <a:latin typeface="Montserrat"/>
+              </a:rPr>
+              <a:t>      –  </a:t>
+            </a:r>
+            <a:r>
+              <a:rPr sz="1350" b="0" i="0">
+                <a:solidFill>
+                  <a:srgbClr val="F1F5F9"/>
+                </a:solidFill>
+                <a:latin typeface="Montserrat"/>
+              </a:rPr>
+              <a:t>Mover os campos do MPR para a nuvem (hoje ficam no navegador de quem digita)</a:t>
+            </a:r>
+          </a:p>
+          <a:p>
+            <a:pPr>
+              <a:spcAft>
+                <a:spcPts val="400"/>
+              </a:spcAft>
+            </a:pPr>
+            <a:r>
+              <a:rPr sz="1350" b="1" i="0">
+                <a:solidFill>
+                  <a:srgbClr val="64748B"/>
+                </a:solidFill>
+                <a:latin typeface="Montserrat"/>
+              </a:rPr>
+              <a:t>      –  </a:t>
+            </a:r>
+            <a:r>
+              <a:rPr sz="1350" b="0" i="0">
+                <a:solidFill>
+                  <a:srgbClr val="F1F5F9"/>
+                </a:solidFill>
+                <a:latin typeface="Montserrat"/>
+              </a:rPr>
+              <a:t>Aviso de “alterações não salvas” no FCA Preenchimento</a:t>
+            </a:r>
+          </a:p>
+          <a:p>
+            <a:pPr>
+              <a:spcAft>
+                <a:spcPts val="400"/>
+              </a:spcAft>
+            </a:pPr>
+            <a:r>
+              <a:rPr sz="1350" b="1" i="0">
+                <a:solidFill>
+                  <a:srgbClr val="64748B"/>
+                </a:solidFill>
+                <a:latin typeface="Montserrat"/>
+              </a:rPr>
+              <a:t>      –  </a:t>
+            </a:r>
+            <a:r>
+              <a:rPr sz="1350" b="0" i="0">
+                <a:solidFill>
+                  <a:srgbClr val="F1F5F9"/>
+                </a:solidFill>
+                <a:latin typeface="Montserrat"/>
+              </a:rPr>
+              <a:t>Rotação de credencial pendente (integração Conlog) — higiene de segurança</a:t>
+            </a:r>
+          </a:p>
+          <a:p>
+            <a:pPr>
+              <a:spcAft>
+                <a:spcPts val="700"/>
+              </a:spcAft>
+            </a:pPr>
+            <a:r>
+              <a:rPr sz="1500" b="1" i="0">
+                <a:solidFill>
+                  <a:srgbClr val="F97316"/>
+                </a:solidFill>
+                <a:latin typeface="Montserrat"/>
+              </a:rPr>
+              <a:t>▪  </a:t>
+            </a:r>
+            <a:r>
+              <a:rPr sz="1500" b="1" i="0">
+                <a:solidFill>
+                  <a:srgbClr val="F97316"/>
+                </a:solidFill>
+                <a:latin typeface="Montserrat"/>
+              </a:rPr>
+              <a:t>Médio prazo:</a:t>
+            </a:r>
+          </a:p>
+          <a:p>
+            <a:pPr>
+              <a:spcAft>
+                <a:spcPts val="400"/>
+              </a:spcAft>
+            </a:pPr>
+            <a:r>
+              <a:rPr sz="1350" b="1" i="0">
+                <a:solidFill>
+                  <a:srgbClr val="64748B"/>
+                </a:solidFill>
+                <a:latin typeface="Montserrat"/>
+              </a:rPr>
+              <a:t>      –  </a:t>
+            </a:r>
+            <a:r>
+              <a:rPr sz="1350" b="0" i="0">
+                <a:solidFill>
+                  <a:srgbClr val="F1F5F9"/>
+                </a:solidFill>
+                <a:latin typeface="Montserrat"/>
+              </a:rPr>
+              <a:t>Notificações (e-mail/WhatsApp) de prazo de ação vencendo</a:t>
+            </a:r>
+          </a:p>
+          <a:p>
+            <a:pPr>
+              <a:spcAft>
+                <a:spcPts val="400"/>
+              </a:spcAft>
+            </a:pPr>
+            <a:r>
+              <a:rPr sz="1350" b="1" i="0">
+                <a:solidFill>
+                  <a:srgbClr val="64748B"/>
+                </a:solidFill>
+                <a:latin typeface="Montserrat"/>
+              </a:rPr>
+              <a:t>      –  </a:t>
+            </a:r>
+            <a:r>
+              <a:rPr sz="1350" b="0" i="0">
+                <a:solidFill>
+                  <a:srgbClr val="F1F5F9"/>
+                </a:solidFill>
+                <a:latin typeface="Montserrat"/>
+              </a:rPr>
+              <a:t>Completar painéis “Em breve” (R$/KM avançado, sub-hubs de clusters)</a:t>
+            </a:r>
+          </a:p>
+          <a:p>
+            <a:pPr>
+              <a:spcAft>
+                <a:spcPts val="400"/>
+              </a:spcAft>
+            </a:pPr>
+            <a:r>
+              <a:rPr sz="1350" b="1" i="0">
+                <a:solidFill>
+                  <a:srgbClr val="64748B"/>
+                </a:solidFill>
+                <a:latin typeface="Montserrat"/>
+              </a:rPr>
+              <a:t>      –  </a:t>
+            </a:r>
+            <a:r>
+              <a:rPr sz="1350" b="0" i="0">
+                <a:solidFill>
+                  <a:srgbClr val="F1F5F9"/>
+                </a:solidFill>
+                <a:latin typeface="Montserrat"/>
+              </a:rPr>
+              <a:t>Trilha de auditoria de edições do FCA (quem alterou o quê)</a:t>
+            </a:r>
+          </a:p>
+          <a:p>
+            <a:pPr>
+              <a:spcAft>
+                <a:spcPts val="700"/>
+              </a:spcAft>
+            </a:pPr>
+            <a:r>
+              <a:rPr sz="1500" b="1" i="0">
+                <a:solidFill>
+                  <a:srgbClr val="F97316"/>
+                </a:solidFill>
+                <a:latin typeface="Montserrat"/>
+              </a:rPr>
+              <a:t>▪  </a:t>
+            </a:r>
+            <a:r>
+              <a:rPr sz="1500" b="1" i="0">
+                <a:solidFill>
+                  <a:srgbClr val="F97316"/>
+                </a:solidFill>
+                <a:latin typeface="Montserrat"/>
+              </a:rPr>
+              <a:t>Contínuo:</a:t>
+            </a:r>
+          </a:p>
+          <a:p>
+            <a:pPr>
+              <a:spcAft>
+                <a:spcPts val="400"/>
+              </a:spcAft>
+            </a:pPr>
+            <a:r>
+              <a:rPr sz="1350" b="1" i="0">
+                <a:solidFill>
+                  <a:srgbClr val="64748B"/>
+                </a:solidFill>
+                <a:latin typeface="Montserrat"/>
+              </a:rPr>
+              <a:t>      –  </a:t>
+            </a:r>
+            <a:r>
+              <a:rPr sz="1350" b="0" i="0">
+                <a:solidFill>
+                  <a:srgbClr val="F1F5F9"/>
+                </a:solidFill>
+                <a:latin typeface="Montserrat"/>
+              </a:rPr>
+              <a:t>Absorção da manutenção pela TI com base na documentação técnica (DOCUMENTACAO-TI.md + deck técnico)</a:t>
+            </a:r>
+          </a:p>
+        </p:txBody>
+      </p:sp>
+      <p:sp>
+        <p:nvSpPr>
+          <p:cNvPr id="6" name="TextBox 5"/>
           <p:cNvSpPr txBox="1"/>
           <p:nvPr/>
         </p:nvSpPr>
@@ -4258,6 +4662,189 @@
                 <a:latin typeface="Montserrat"/>
               </a:rPr>
               <a:t>Visão Executiva  ·  12</a:t>
+            </a:r>
+          </a:p>
+        </p:txBody>
+      </p:sp>
+    </p:spTree>
+  </p:cSld>
+  <p:clrMapOvr>
+    <a:masterClrMapping/>
+  </p:clrMapOvr>
+</p:sld>
+</file>
+
+<file path=ppt/slides/slide13.xml><?xml version="1.0" encoding="utf-8"?>
+<p:sld xmlns:a="http://schemas.openxmlformats.org/drawingml/2006/main" xmlns:p="http://schemas.openxmlformats.org/presentationml/2006/main" xmlns:r="http://schemas.openxmlformats.org/officeDocument/2006/relationships">
+  <p:cSld>
+    <p:bg>
+      <p:bgPr>
+        <a:solidFill>
+          <a:srgbClr val="0C1017"/>
+        </a:solidFill>
+        <a:effectLst/>
+      </p:bgPr>
+    </p:bg>
+    <p:spTree>
+      <p:nvGrpSpPr>
+        <p:cNvPr id="1" name=""/>
+        <p:cNvGrpSpPr/>
+        <p:nvPr/>
+      </p:nvGrpSpPr>
+      <p:grpSpPr/>
+      <p:sp>
+        <p:nvSpPr>
+          <p:cNvPr id="2" name="Rectangle 1"/>
+          <p:cNvSpPr/>
+          <p:nvPr/>
+        </p:nvSpPr>
+        <p:spPr>
+          <a:xfrm>
+            <a:off x="548640" y="3200400"/>
+            <a:ext cx="2377440" cy="38100"/>
+          </a:xfrm>
+          <a:prstGeom prst="rect">
+            <a:avLst/>
+          </a:prstGeom>
+          <a:solidFill>
+            <a:srgbClr val="F97316"/>
+          </a:solidFill>
+          <a:ln>
+            <a:noFill/>
+          </a:ln>
+        </p:spPr>
+        <p:style>
+          <a:lnRef idx="1">
+            <a:schemeClr val="accent1"/>
+          </a:lnRef>
+          <a:fillRef idx="3">
+            <a:schemeClr val="accent1"/>
+          </a:fillRef>
+          <a:effectRef idx="2">
+            <a:schemeClr val="accent1"/>
+          </a:effectRef>
+          <a:fontRef idx="minor">
+            <a:schemeClr val="lt1"/>
+          </a:fontRef>
+        </p:style>
+        <p:txBody>
+          <a:bodyPr rtlCol="0" anchor="ctr"/>
+          <a:lstStyle/>
+          <a:p>
+            <a:pPr algn="ctr"/>
+          </a:p>
+        </p:txBody>
+      </p:sp>
+      <p:sp>
+        <p:nvSpPr>
+          <p:cNvPr id="3" name="TextBox 2"/>
+          <p:cNvSpPr txBox="1"/>
+          <p:nvPr/>
+        </p:nvSpPr>
+        <p:spPr>
+          <a:xfrm>
+            <a:off x="548640" y="2011680"/>
+            <a:ext cx="10972800" cy="1188720"/>
+          </a:xfrm>
+          <a:prstGeom prst="rect">
+            <a:avLst/>
+          </a:prstGeom>
+          <a:noFill/>
+        </p:spPr>
+        <p:txBody>
+          <a:bodyPr wrap="square">
+            <a:spAutoFit/>
+          </a:bodyPr>
+          <a:lstStyle/>
+          <a:p>
+            <a:r>
+              <a:rPr sz="4000" b="1" i="0">
+                <a:solidFill>
+                  <a:srgbClr val="F1F5F9"/>
+                </a:solidFill>
+                <a:latin typeface="Montserrat"/>
+              </a:rPr>
+              <a:t>Gestão em Movimento</a:t>
+            </a:r>
+          </a:p>
+        </p:txBody>
+      </p:sp>
+      <p:sp>
+        <p:nvSpPr>
+          <p:cNvPr id="4" name="TextBox 3"/>
+          <p:cNvSpPr txBox="1"/>
+          <p:nvPr/>
+        </p:nvSpPr>
+        <p:spPr>
+          <a:xfrm>
+            <a:off x="548640" y="3429000"/>
+            <a:ext cx="10972800" cy="2011680"/>
+          </a:xfrm>
+          <a:prstGeom prst="rect">
+            <a:avLst/>
+          </a:prstGeom>
+          <a:noFill/>
+        </p:spPr>
+        <p:txBody>
+          <a:bodyPr wrap="square">
+            <a:spAutoFit/>
+          </a:bodyPr>
+          <a:lstStyle/>
+          <a:p>
+            <a:r>
+              <a:rPr sz="1800" b="0" i="0">
+                <a:solidFill>
+                  <a:srgbClr val="94A3B8"/>
+                </a:solidFill>
+                <a:latin typeface="Montserrat"/>
+              </a:rPr>
+              <a:t>Do indicador à ação — a gestão da frota inteira num só lugar.</a:t>
+            </a:r>
+          </a:p>
+          <a:p>
+            <a:r>
+              <a:rPr sz="1400" b="1" i="0">
+                <a:solidFill>
+                  <a:srgbClr val="F97316"/>
+                </a:solidFill>
+                <a:latin typeface="Montserrat"/>
+              </a:rPr>
+              <a:t>fortesindicadores-byte.github.io/gestao-em-movimento</a:t>
+            </a:r>
+          </a:p>
+        </p:txBody>
+      </p:sp>
+      <p:sp>
+        <p:nvSpPr>
+          <p:cNvPr id="5" name="TextBox 4"/>
+          <p:cNvSpPr txBox="1"/>
+          <p:nvPr/>
+        </p:nvSpPr>
+        <p:spPr>
+          <a:xfrm>
+            <a:off x="548640" y="6473952"/>
+            <a:ext cx="11064240" cy="320040"/>
+          </a:xfrm>
+          <a:prstGeom prst="rect">
+            <a:avLst/>
+          </a:prstGeom>
+          <a:noFill/>
+        </p:spPr>
+        <p:txBody>
+          <a:bodyPr wrap="square">
+            <a:spAutoFit/>
+          </a:bodyPr>
+          <a:lstStyle/>
+          <a:p>
+            <a:pPr algn="r"/>
+            <a:r>
+              <a:rPr sz="900" b="0" i="0">
+                <a:solidFill>
+                  <a:srgbClr val="64748B"/>
+                </a:solidFill>
+                <a:latin typeface="Montserrat"/>
+              </a:rPr>
+              <a:t>Visão Executiva  ·  13</a:t>
             </a:r>
           </a:p>
         </p:txBody>
@@ -7520,563 +8107,32 @@
                 </a:solidFill>
                 <a:latin typeface="Montserrat"/>
               </a:rPr>
-              <a:t>Modelo operacional — a rotina do mês</a:t>
-            </a:r>
-          </a:p>
-        </p:txBody>
-      </p:sp>
-      <p:sp>
-        <p:nvSpPr>
-          <p:cNvPr id="5" name="Rounded Rectangle 4"/>
-          <p:cNvSpPr/>
-          <p:nvPr/>
-        </p:nvSpPr>
-        <p:spPr>
-          <a:xfrm>
-            <a:off x="548640" y="1828800"/>
-            <a:ext cx="2103120" cy="2103120"/>
-          </a:xfrm>
-          <a:prstGeom prst="roundRect">
-            <a:avLst/>
-          </a:prstGeom>
-          <a:solidFill>
-            <a:srgbClr val="141B26"/>
-          </a:solidFill>
-          <a:ln w="12700">
-            <a:solidFill>
-              <a:srgbClr val="1E2D40"/>
-            </a:solidFill>
-          </a:ln>
-        </p:spPr>
-        <p:style>
-          <a:lnRef idx="1">
-            <a:schemeClr val="accent1"/>
-          </a:lnRef>
-          <a:fillRef idx="3">
-            <a:schemeClr val="accent1"/>
-          </a:fillRef>
-          <a:effectRef idx="2">
-            <a:schemeClr val="accent1"/>
-          </a:effectRef>
-          <a:fontRef idx="minor">
-            <a:schemeClr val="lt1"/>
-          </a:fontRef>
-        </p:style>
-        <p:txBody>
-          <a:bodyPr rtlCol="0" anchor="t" wrap="square" lIns="146304" rIns="128016" tIns="91440" bIns="73152"/>
-          <a:lstStyle/>
-          <a:p>
-            <a:pPr algn="ctr">
-              <a:spcAft>
-                <a:spcPts val="400"/>
-              </a:spcAft>
-            </a:pPr>
-            <a:r>
-              <a:rPr sz="1200" b="1" i="0">
-                <a:solidFill>
-                  <a:srgbClr val="F97316"/>
-                </a:solidFill>
-                <a:latin typeface="Montserrat"/>
-              </a:rPr>
-              <a:t>1 · FECHAMENTO</a:t>
-            </a:r>
-          </a:p>
-          <a:p>
-            <a:pPr>
-              <a:spcAft>
-                <a:spcPts val="200"/>
-              </a:spcAft>
-            </a:pPr>
-            <a:r>
-              <a:rPr sz="1100" b="0" i="0">
+              <a:t>Farol da Frota — a foto de segunda</a:t>
+            </a:r>
+          </a:p>
+          <a:p>
+            <a:r>
+              <a:rPr sz="1200" b="0" i="0">
                 <a:solidFill>
                   <a:srgbClr val="94A3B8"/>
                 </a:solidFill>
                 <a:latin typeface="Montserrat"/>
               </a:rPr>
-              <a:t>Mês fecha; bases oficiais atualizadas (DRE, RPM, termômetro)</a:t>
-            </a:r>
-          </a:p>
-        </p:txBody>
-      </p:sp>
-      <p:sp>
-        <p:nvSpPr>
-          <p:cNvPr id="6" name="Right Arrow 5"/>
-          <p:cNvSpPr/>
-          <p:nvPr/>
-        </p:nvSpPr>
-        <p:spPr>
-          <a:xfrm>
-            <a:off x="2670048" y="2697480"/>
-            <a:ext cx="219456" cy="292608"/>
-          </a:xfrm>
-          <a:prstGeom prst="rightArrow">
-            <a:avLst/>
-          </a:prstGeom>
-          <a:solidFill>
-            <a:srgbClr val="F97316"/>
-          </a:solidFill>
-          <a:ln>
-            <a:noFill/>
-          </a:ln>
-        </p:spPr>
-        <p:style>
-          <a:lnRef idx="1">
-            <a:schemeClr val="accent1"/>
-          </a:lnRef>
-          <a:fillRef idx="3">
-            <a:schemeClr val="accent1"/>
-          </a:fillRef>
-          <a:effectRef idx="2">
-            <a:schemeClr val="accent1"/>
-          </a:effectRef>
-          <a:fontRef idx="minor">
-            <a:schemeClr val="lt1"/>
-          </a:fontRef>
-        </p:style>
-        <p:txBody>
-          <a:bodyPr rtlCol="0" anchor="ctr"/>
-          <a:lstStyle/>
-          <a:p>
-            <a:pPr algn="ctr"/>
-          </a:p>
-        </p:txBody>
-      </p:sp>
-      <p:sp>
-        <p:nvSpPr>
-          <p:cNvPr id="7" name="Rounded Rectangle 6"/>
-          <p:cNvSpPr/>
-          <p:nvPr/>
-        </p:nvSpPr>
-        <p:spPr>
-          <a:xfrm>
-            <a:off x="2807208" y="1828800"/>
-            <a:ext cx="2103120" cy="2103120"/>
-          </a:xfrm>
-          <a:prstGeom prst="roundRect">
-            <a:avLst/>
-          </a:prstGeom>
-          <a:solidFill>
-            <a:srgbClr val="141B26"/>
-          </a:solidFill>
-          <a:ln w="12700">
-            <a:solidFill>
-              <a:srgbClr val="1E2D40"/>
-            </a:solidFill>
-          </a:ln>
-        </p:spPr>
-        <p:style>
-          <a:lnRef idx="1">
-            <a:schemeClr val="accent1"/>
-          </a:lnRef>
-          <a:fillRef idx="3">
-            <a:schemeClr val="accent1"/>
-          </a:fillRef>
-          <a:effectRef idx="2">
-            <a:schemeClr val="accent1"/>
-          </a:effectRef>
-          <a:fontRef idx="minor">
-            <a:schemeClr val="lt1"/>
-          </a:fontRef>
-        </p:style>
-        <p:txBody>
-          <a:bodyPr rtlCol="0" anchor="t" wrap="square" lIns="146304" rIns="128016" tIns="91440" bIns="73152"/>
-          <a:lstStyle/>
-          <a:p>
-            <a:pPr algn="ctr">
-              <a:spcAft>
-                <a:spcPts val="400"/>
-              </a:spcAft>
-            </a:pPr>
-            <a:r>
-              <a:rPr sz="1200" b="1" i="0">
-                <a:solidFill>
-                  <a:srgbClr val="F97316"/>
-                </a:solidFill>
-                <a:latin typeface="Montserrat"/>
-              </a:rPr>
-              <a:t>2 · GERAÇÃO</a:t>
-            </a:r>
-          </a:p>
-          <a:p>
-            <a:pPr>
-              <a:spcAft>
-                <a:spcPts val="200"/>
-              </a:spcAft>
-            </a:pPr>
-            <a:r>
-              <a:rPr sz="1100" b="0" i="0">
-                <a:solidFill>
-                  <a:srgbClr val="94A3B8"/>
-                </a:solidFill>
-                <a:latin typeface="Montserrat"/>
-              </a:rPr>
-              <a:t>Admin clica 2 botões e o sistema cria todos os desvios do mês</a:t>
-            </a:r>
-          </a:p>
-        </p:txBody>
-      </p:sp>
-      <p:sp>
-        <p:nvSpPr>
-          <p:cNvPr id="8" name="Right Arrow 7"/>
-          <p:cNvSpPr/>
-          <p:nvPr/>
-        </p:nvSpPr>
-        <p:spPr>
-          <a:xfrm>
-            <a:off x="4928616" y="2697480"/>
-            <a:ext cx="219456" cy="292608"/>
-          </a:xfrm>
-          <a:prstGeom prst="rightArrow">
-            <a:avLst/>
-          </a:prstGeom>
-          <a:solidFill>
-            <a:srgbClr val="F97316"/>
-          </a:solidFill>
-          <a:ln>
-            <a:noFill/>
-          </a:ln>
-        </p:spPr>
-        <p:style>
-          <a:lnRef idx="1">
-            <a:schemeClr val="accent1"/>
-          </a:lnRef>
-          <a:fillRef idx="3">
-            <a:schemeClr val="accent1"/>
-          </a:fillRef>
-          <a:effectRef idx="2">
-            <a:schemeClr val="accent1"/>
-          </a:effectRef>
-          <a:fontRef idx="minor">
-            <a:schemeClr val="lt1"/>
-          </a:fontRef>
-        </p:style>
-        <p:txBody>
-          <a:bodyPr rtlCol="0" anchor="ctr"/>
-          <a:lstStyle/>
-          <a:p>
-            <a:pPr algn="ctr"/>
-          </a:p>
-        </p:txBody>
-      </p:sp>
-      <p:sp>
-        <p:nvSpPr>
-          <p:cNvPr id="9" name="Rounded Rectangle 8"/>
-          <p:cNvSpPr/>
-          <p:nvPr/>
-        </p:nvSpPr>
-        <p:spPr>
-          <a:xfrm>
-            <a:off x="5065776" y="1828800"/>
-            <a:ext cx="2103120" cy="2103120"/>
-          </a:xfrm>
-          <a:prstGeom prst="roundRect">
-            <a:avLst/>
-          </a:prstGeom>
-          <a:solidFill>
-            <a:srgbClr val="141B26"/>
-          </a:solidFill>
-          <a:ln w="12700">
-            <a:solidFill>
-              <a:srgbClr val="1E2D40"/>
-            </a:solidFill>
-          </a:ln>
-        </p:spPr>
-        <p:style>
-          <a:lnRef idx="1">
-            <a:schemeClr val="accent1"/>
-          </a:lnRef>
-          <a:fillRef idx="3">
-            <a:schemeClr val="accent1"/>
-          </a:fillRef>
-          <a:effectRef idx="2">
-            <a:schemeClr val="accent1"/>
-          </a:effectRef>
-          <a:fontRef idx="minor">
-            <a:schemeClr val="lt1"/>
-          </a:fontRef>
-        </p:style>
-        <p:txBody>
-          <a:bodyPr rtlCol="0" anchor="t" wrap="square" lIns="146304" rIns="128016" tIns="91440" bIns="73152"/>
-          <a:lstStyle/>
-          <a:p>
-            <a:pPr algn="ctr">
-              <a:spcAft>
-                <a:spcPts val="400"/>
-              </a:spcAft>
-            </a:pPr>
-            <a:r>
-              <a:rPr sz="1200" b="1" i="0">
-                <a:solidFill>
-                  <a:srgbClr val="F97316"/>
-                </a:solidFill>
-                <a:latin typeface="Montserrat"/>
-              </a:rPr>
-              <a:t>3 · TRATAMENTO</a:t>
-            </a:r>
-          </a:p>
-          <a:p>
-            <a:pPr>
-              <a:spcAft>
-                <a:spcPts val="200"/>
-              </a:spcAft>
-            </a:pPr>
-            <a:r>
-              <a:rPr sz="1100" b="0" i="0">
-                <a:solidFill>
-                  <a:srgbClr val="94A3B8"/>
-                </a:solidFill>
-                <a:latin typeface="Montserrat"/>
-              </a:rPr>
-              <a:t>Cada unidade preenche causa, ação, responsável e prazo</a:t>
-            </a:r>
-          </a:p>
-        </p:txBody>
-      </p:sp>
-      <p:sp>
-        <p:nvSpPr>
-          <p:cNvPr id="10" name="Right Arrow 9"/>
-          <p:cNvSpPr/>
-          <p:nvPr/>
-        </p:nvSpPr>
-        <p:spPr>
-          <a:xfrm>
-            <a:off x="7187184" y="2697480"/>
-            <a:ext cx="219456" cy="292608"/>
-          </a:xfrm>
-          <a:prstGeom prst="rightArrow">
-            <a:avLst/>
-          </a:prstGeom>
-          <a:solidFill>
-            <a:srgbClr val="F97316"/>
-          </a:solidFill>
-          <a:ln>
-            <a:noFill/>
-          </a:ln>
-        </p:spPr>
-        <p:style>
-          <a:lnRef idx="1">
-            <a:schemeClr val="accent1"/>
-          </a:lnRef>
-          <a:fillRef idx="3">
-            <a:schemeClr val="accent1"/>
-          </a:fillRef>
-          <a:effectRef idx="2">
-            <a:schemeClr val="accent1"/>
-          </a:effectRef>
-          <a:fontRef idx="minor">
-            <a:schemeClr val="lt1"/>
-          </a:fontRef>
-        </p:style>
-        <p:txBody>
-          <a:bodyPr rtlCol="0" anchor="ctr"/>
-          <a:lstStyle/>
-          <a:p>
-            <a:pPr algn="ctr"/>
-          </a:p>
-        </p:txBody>
-      </p:sp>
-      <p:sp>
-        <p:nvSpPr>
-          <p:cNvPr id="11" name="Rounded Rectangle 10"/>
-          <p:cNvSpPr/>
-          <p:nvPr/>
-        </p:nvSpPr>
-        <p:spPr>
-          <a:xfrm>
-            <a:off x="7324344" y="1828800"/>
-            <a:ext cx="2103120" cy="2103120"/>
-          </a:xfrm>
-          <a:prstGeom prst="roundRect">
-            <a:avLst/>
-          </a:prstGeom>
-          <a:solidFill>
-            <a:srgbClr val="141B26"/>
-          </a:solidFill>
-          <a:ln w="12700">
-            <a:solidFill>
-              <a:srgbClr val="1E2D40"/>
-            </a:solidFill>
-          </a:ln>
-        </p:spPr>
-        <p:style>
-          <a:lnRef idx="1">
-            <a:schemeClr val="accent1"/>
-          </a:lnRef>
-          <a:fillRef idx="3">
-            <a:schemeClr val="accent1"/>
-          </a:fillRef>
-          <a:effectRef idx="2">
-            <a:schemeClr val="accent1"/>
-          </a:effectRef>
-          <a:fontRef idx="minor">
-            <a:schemeClr val="lt1"/>
-          </a:fontRef>
-        </p:style>
-        <p:txBody>
-          <a:bodyPr rtlCol="0" anchor="t" wrap="square" lIns="146304" rIns="128016" tIns="91440" bIns="73152"/>
-          <a:lstStyle/>
-          <a:p>
-            <a:pPr algn="ctr">
-              <a:spcAft>
-                <a:spcPts val="400"/>
-              </a:spcAft>
-            </a:pPr>
-            <a:r>
-              <a:rPr sz="1200" b="1" i="0">
-                <a:solidFill>
-                  <a:srgbClr val="F97316"/>
-                </a:solidFill>
-                <a:latin typeface="Montserrat"/>
-              </a:rPr>
-              <a:t>4 · REUNIÃO (MPR)</a:t>
-            </a:r>
-          </a:p>
-          <a:p>
-            <a:pPr>
-              <a:spcAft>
-                <a:spcPts val="200"/>
-              </a:spcAft>
-            </a:pPr>
-            <a:r>
-              <a:rPr sz="1100" b="0" i="0">
-                <a:solidFill>
-                  <a:srgbClr val="94A3B8"/>
-                </a:solidFill>
-                <a:latin typeface="Montserrat"/>
-              </a:rPr>
-              <a:t>Resultados e planos revisados na mesa mensal</a:t>
-            </a:r>
-          </a:p>
-        </p:txBody>
-      </p:sp>
-      <p:sp>
-        <p:nvSpPr>
-          <p:cNvPr id="12" name="Right Arrow 11"/>
-          <p:cNvSpPr/>
-          <p:nvPr/>
-        </p:nvSpPr>
-        <p:spPr>
-          <a:xfrm>
-            <a:off x="9445752" y="2697480"/>
-            <a:ext cx="219456" cy="292608"/>
-          </a:xfrm>
-          <a:prstGeom prst="rightArrow">
-            <a:avLst/>
-          </a:prstGeom>
-          <a:solidFill>
-            <a:srgbClr val="F97316"/>
-          </a:solidFill>
-          <a:ln>
-            <a:noFill/>
-          </a:ln>
-        </p:spPr>
-        <p:style>
-          <a:lnRef idx="1">
-            <a:schemeClr val="accent1"/>
-          </a:lnRef>
-          <a:fillRef idx="3">
-            <a:schemeClr val="accent1"/>
-          </a:fillRef>
-          <a:effectRef idx="2">
-            <a:schemeClr val="accent1"/>
-          </a:effectRef>
-          <a:fontRef idx="minor">
-            <a:schemeClr val="lt1"/>
-          </a:fontRef>
-        </p:style>
-        <p:txBody>
-          <a:bodyPr rtlCol="0" anchor="ctr"/>
-          <a:lstStyle/>
-          <a:p>
-            <a:pPr algn="ctr"/>
-          </a:p>
-        </p:txBody>
-      </p:sp>
-      <p:sp>
-        <p:nvSpPr>
-          <p:cNvPr id="13" name="Rounded Rectangle 12"/>
-          <p:cNvSpPr/>
-          <p:nvPr/>
-        </p:nvSpPr>
-        <p:spPr>
-          <a:xfrm>
-            <a:off x="9582912" y="1828800"/>
-            <a:ext cx="2103120" cy="2103120"/>
-          </a:xfrm>
-          <a:prstGeom prst="roundRect">
-            <a:avLst/>
-          </a:prstGeom>
-          <a:solidFill>
-            <a:srgbClr val="141B26"/>
-          </a:solidFill>
-          <a:ln w="12700">
-            <a:solidFill>
-              <a:srgbClr val="1E2D40"/>
-            </a:solidFill>
-          </a:ln>
-        </p:spPr>
-        <p:style>
-          <a:lnRef idx="1">
-            <a:schemeClr val="accent1"/>
-          </a:lnRef>
-          <a:fillRef idx="3">
-            <a:schemeClr val="accent1"/>
-          </a:fillRef>
-          <a:effectRef idx="2">
-            <a:schemeClr val="accent1"/>
-          </a:effectRef>
-          <a:fontRef idx="minor">
-            <a:schemeClr val="lt1"/>
-          </a:fontRef>
-        </p:style>
-        <p:txBody>
-          <a:bodyPr rtlCol="0" anchor="t" wrap="square" lIns="146304" rIns="128016" tIns="91440" bIns="73152"/>
-          <a:lstStyle/>
-          <a:p>
-            <a:pPr algn="ctr">
-              <a:spcAft>
-                <a:spcPts val="400"/>
-              </a:spcAft>
-            </a:pPr>
-            <a:r>
-              <a:rPr sz="1200" b="1" i="0">
-                <a:solidFill>
-                  <a:srgbClr val="F97316"/>
-                </a:solidFill>
-                <a:latin typeface="Montserrat"/>
-              </a:rPr>
-              <a:t>5 · ACOMPANHAMENTO</a:t>
-            </a:r>
-          </a:p>
-          <a:p>
-            <a:pPr>
-              <a:spcAft>
-                <a:spcPts val="200"/>
-              </a:spcAft>
-            </a:pPr>
-            <a:r>
-              <a:rPr sz="1100" b="0" i="0">
-                <a:solidFill>
-                  <a:srgbClr val="94A3B8"/>
-                </a:solidFill>
-                <a:latin typeface="Montserrat"/>
-              </a:rPr>
-              <a:t>Aderência, kanban e termômetro até o próximo ciclo</a:t>
-            </a:r>
-          </a:p>
-        </p:txBody>
-      </p:sp>
-      <p:sp>
-        <p:nvSpPr>
-          <p:cNvPr id="14" name="TextBox 13"/>
+              <a:t>Cada gestor recebe seu retrato semanal por e-mail</a:t>
+            </a:r>
+          </a:p>
+        </p:txBody>
+      </p:sp>
+      <p:sp>
+        <p:nvSpPr>
+          <p:cNvPr id="5" name="TextBox 4"/>
           <p:cNvSpPr txBox="1"/>
           <p:nvPr/>
         </p:nvSpPr>
         <p:spPr>
           <a:xfrm>
-            <a:off x="548640" y="4389120"/>
-            <a:ext cx="11064240" cy="1280160"/>
+            <a:off x="548640" y="1417320"/>
+            <a:ext cx="11064240" cy="5120640"/>
           </a:xfrm>
           <a:prstGeom prst="rect">
             <a:avLst/>
@@ -8089,21 +8145,110 @@
           </a:bodyPr>
           <a:lstStyle/>
           <a:p>
-            <a:r>
-              <a:rPr sz="1400" b="1" i="0">
-                <a:solidFill>
-                  <a:srgbClr val="94A3B8"/>
-                </a:solidFill>
-                <a:latin typeface="Montserrat"/>
-              </a:rPr>
-              <a:t>Sem carga manual de dados, sem consolidação em Excel: o portal lê as fontes e conduz o processo.</a:t>
-            </a:r>
-          </a:p>
-        </p:txBody>
-      </p:sp>
-      <p:sp>
-        <p:nvSpPr>
-          <p:cNvPr id="15" name="TextBox 14"/>
+            <a:pPr>
+              <a:spcAft>
+                <a:spcPts val="700"/>
+              </a:spcAft>
+            </a:pPr>
+            <a:r>
+              <a:rPr sz="1500" b="1" i="0">
+                <a:solidFill>
+                  <a:srgbClr val="F97316"/>
+                </a:solidFill>
+                <a:latin typeface="Montserrat"/>
+              </a:rPr>
+              <a:t>▪  </a:t>
+            </a:r>
+            <a:r>
+              <a:rPr sz="1500" b="0" i="0">
+                <a:solidFill>
+                  <a:srgbClr val="F1F5F9"/>
+                </a:solidFill>
+                <a:latin typeface="Montserrat"/>
+              </a:rPr>
+              <a:t>Um raio-x semanal da frota, por unidade: custos, stress test, CIFV, preventivas, alinhamento, OSs, disponibilidade e pneus.</a:t>
+            </a:r>
+          </a:p>
+          <a:p>
+            <a:pPr>
+              <a:spcAft>
+                <a:spcPts val="700"/>
+              </a:spcAft>
+            </a:pPr>
+            <a:r>
+              <a:rPr sz="1500" b="1" i="0">
+                <a:solidFill>
+                  <a:srgbClr val="F97316"/>
+                </a:solidFill>
+                <a:latin typeface="Montserrat"/>
+              </a:rPr>
+              <a:t>▪  </a:t>
+            </a:r>
+            <a:r>
+              <a:rPr sz="1500" b="0" i="0">
+                <a:solidFill>
+                  <a:srgbClr val="F1F5F9"/>
+                </a:solidFill>
+                <a:latin typeface="Montserrat"/>
+              </a:rPr>
+              <a:t>A foto é tirada toda segunda às 14h — o gestor recebe no e-mail, sem precisar entrar no portal.</a:t>
+            </a:r>
+          </a:p>
+          <a:p>
+            <a:pPr>
+              <a:spcAft>
+                <a:spcPts val="700"/>
+              </a:spcAft>
+            </a:pPr>
+            <a:r>
+              <a:rPr sz="1500" b="1" i="0">
+                <a:solidFill>
+                  <a:srgbClr val="F97316"/>
+                </a:solidFill>
+                <a:latin typeface="Montserrat"/>
+              </a:rPr>
+              <a:t>▪  </a:t>
+            </a:r>
+            <a:r>
+              <a:rPr sz="1500" b="0" i="0">
+                <a:solidFill>
+                  <a:srgbClr val="F1F5F9"/>
+                </a:solidFill>
+                <a:latin typeface="Montserrat"/>
+              </a:rPr>
+              <a:t>Visão geral com Ranking das Unidades e Resumo Executivo: o que está bom, o que é crítico e os próximos passos.</a:t>
+            </a:r>
+          </a:p>
+          <a:p>
+            <a:pPr>
+              <a:spcAft>
+                <a:spcPts val="700"/>
+              </a:spcAft>
+            </a:pPr>
+            <a:r>
+              <a:rPr sz="1500" b="1" i="0">
+                <a:solidFill>
+                  <a:srgbClr val="F97316"/>
+                </a:solidFill>
+                <a:latin typeface="Montserrat"/>
+              </a:rPr>
+              <a:t>▪  </a:t>
+            </a:r>
+            <a:r>
+              <a:rPr sz="1500" b="0" i="0">
+                <a:solidFill>
+                  <a:srgbClr val="F1F5F9"/>
+                </a:solidFill>
+                <a:latin typeface="Montserrat"/>
+              </a:rPr>
+              <a:t>Liberação simples: no Gerenciar Acessos marca-se de quais unidades cada pessoa recebe o Farol.</a:t>
+            </a:r>
+          </a:p>
+        </p:txBody>
+      </p:sp>
+      <p:sp>
+        <p:nvSpPr>
+          <p:cNvPr id="6" name="TextBox 5"/>
           <p:cNvSpPr txBox="1"/>
           <p:nvPr/>
         </p:nvSpPr>
@@ -8288,7 +8433,7 @@
                 </a:solidFill>
                 <a:latin typeface="Montserrat"/>
               </a:rPr>
-              <a:t>Benefícios</a:t>
+              <a:t>Modelo operacional — a rotina do mês</a:t>
             </a:r>
           </a:p>
         </p:txBody>
@@ -8301,8 +8446,8 @@
         </p:nvSpPr>
         <p:spPr>
           <a:xfrm>
-            <a:off x="548640" y="1554480"/>
-            <a:ext cx="5394960" cy="1417320"/>
+            <a:off x="548640" y="1828800"/>
+            <a:ext cx="2103120" cy="2103120"/>
           </a:xfrm>
           <a:prstGeom prst="roundRect">
             <a:avLst/>
@@ -8340,13 +8485,13 @@
               </a:spcAft>
             </a:pPr>
             <a:r>
-              <a:rPr sz="1300" b="1" i="0">
-                <a:solidFill>
-                  <a:srgbClr val="3BB33B"/>
-                </a:solidFill>
-                <a:latin typeface="Montserrat"/>
-              </a:rPr>
-              <a:t>CUSTO ≈ ZERO DE INFRAESTRUTURA</a:t>
+              <a:rPr sz="1200" b="1" i="0">
+                <a:solidFill>
+                  <a:srgbClr val="F97316"/>
+                </a:solidFill>
+                <a:latin typeface="Montserrat"/>
+              </a:rPr>
+              <a:t>1 · FECHAMENTO</a:t>
             </a:r>
           </a:p>
           <a:p>
@@ -8362,37 +8507,64 @@
                 </a:solidFill>
                 <a:latin typeface="Montserrat"/>
               </a:rPr>
-              <a:t>Hospedagem e automações em camadas gratuitas;</a:t>
-            </a:r>
-          </a:p>
-          <a:p>
-            <a:pPr>
-              <a:spcAft>
-                <a:spcPts val="200"/>
-              </a:spcAft>
-            </a:pPr>
-            <a:r>
-              <a:rPr sz="1100" b="0" i="0">
-                <a:solidFill>
-                  <a:srgbClr val="94A3B8"/>
-                </a:solidFill>
-                <a:latin typeface="Montserrat"/>
-              </a:rPr>
-              <a:t>sem licença por usuário (vs. ferramenta paga de BI)</a:t>
-            </a:r>
-          </a:p>
-        </p:txBody>
-      </p:sp>
-      <p:sp>
-        <p:nvSpPr>
-          <p:cNvPr id="6" name="Rounded Rectangle 5"/>
+              <a:t>Mês fecha; bases oficiais atualizadas (DRE, RPM, termômetro)</a:t>
+            </a:r>
+          </a:p>
+        </p:txBody>
+      </p:sp>
+      <p:sp>
+        <p:nvSpPr>
+          <p:cNvPr id="6" name="Right Arrow 5"/>
           <p:cNvSpPr/>
           <p:nvPr/>
         </p:nvSpPr>
         <p:spPr>
           <a:xfrm>
-            <a:off x="6217920" y="1554480"/>
-            <a:ext cx="5394960" cy="1417320"/>
+            <a:off x="2670048" y="2697480"/>
+            <a:ext cx="219456" cy="292608"/>
+          </a:xfrm>
+          <a:prstGeom prst="rightArrow">
+            <a:avLst/>
+          </a:prstGeom>
+          <a:solidFill>
+            <a:srgbClr val="F97316"/>
+          </a:solidFill>
+          <a:ln>
+            <a:noFill/>
+          </a:ln>
+        </p:spPr>
+        <p:style>
+          <a:lnRef idx="1">
+            <a:schemeClr val="accent1"/>
+          </a:lnRef>
+          <a:fillRef idx="3">
+            <a:schemeClr val="accent1"/>
+          </a:fillRef>
+          <a:effectRef idx="2">
+            <a:schemeClr val="accent1"/>
+          </a:effectRef>
+          <a:fontRef idx="minor">
+            <a:schemeClr val="lt1"/>
+          </a:fontRef>
+        </p:style>
+        <p:txBody>
+          <a:bodyPr rtlCol="0" anchor="ctr"/>
+          <a:lstStyle/>
+          <a:p>
+            <a:pPr algn="ctr"/>
+          </a:p>
+        </p:txBody>
+      </p:sp>
+      <p:sp>
+        <p:nvSpPr>
+          <p:cNvPr id="7" name="Rounded Rectangle 6"/>
+          <p:cNvSpPr/>
+          <p:nvPr/>
+        </p:nvSpPr>
+        <p:spPr>
+          <a:xfrm>
+            <a:off x="2807208" y="1828800"/>
+            <a:ext cx="2103120" cy="2103120"/>
           </a:xfrm>
           <a:prstGeom prst="roundRect">
             <a:avLst/>
@@ -8430,13 +8602,13 @@
               </a:spcAft>
             </a:pPr>
             <a:r>
-              <a:rPr sz="1300" b="1" i="0">
-                <a:solidFill>
-                  <a:srgbClr val="3BB33B"/>
-                </a:solidFill>
-                <a:latin typeface="Montserrat"/>
-              </a:rPr>
-              <a:t>FONTE ÚNICA DA VERDADE</a:t>
+              <a:rPr sz="1200" b="1" i="0">
+                <a:solidFill>
+                  <a:srgbClr val="F97316"/>
+                </a:solidFill>
+                <a:latin typeface="Montserrat"/>
+              </a:rPr>
+              <a:t>2 · GERAÇÃO</a:t>
             </a:r>
           </a:p>
           <a:p>
@@ -8452,37 +8624,64 @@
                 </a:solidFill>
                 <a:latin typeface="Montserrat"/>
               </a:rPr>
-              <a:t>Mesmo número em todos os painéis;</a:t>
-            </a:r>
-          </a:p>
-          <a:p>
-            <a:pPr>
-              <a:spcAft>
-                <a:spcPts val="200"/>
-              </a:spcAft>
-            </a:pPr>
-            <a:r>
-              <a:rPr sz="1100" b="0" i="0">
-                <a:solidFill>
-                  <a:srgbClr val="94A3B8"/>
-                </a:solidFill>
-                <a:latin typeface="Montserrat"/>
-              </a:rPr>
-              <a:t>planos de ação centralizados e auditáveis na nuvem</a:t>
-            </a:r>
-          </a:p>
-        </p:txBody>
-      </p:sp>
-      <p:sp>
-        <p:nvSpPr>
-          <p:cNvPr id="7" name="Rounded Rectangle 6"/>
+              <a:t>Admin clica 2 botões e o sistema cria todos os desvios do mês</a:t>
+            </a:r>
+          </a:p>
+        </p:txBody>
+      </p:sp>
+      <p:sp>
+        <p:nvSpPr>
+          <p:cNvPr id="8" name="Right Arrow 7"/>
           <p:cNvSpPr/>
           <p:nvPr/>
         </p:nvSpPr>
         <p:spPr>
           <a:xfrm>
-            <a:off x="548640" y="3154680"/>
-            <a:ext cx="5394960" cy="1417320"/>
+            <a:off x="4928616" y="2697480"/>
+            <a:ext cx="219456" cy="292608"/>
+          </a:xfrm>
+          <a:prstGeom prst="rightArrow">
+            <a:avLst/>
+          </a:prstGeom>
+          <a:solidFill>
+            <a:srgbClr val="F97316"/>
+          </a:solidFill>
+          <a:ln>
+            <a:noFill/>
+          </a:ln>
+        </p:spPr>
+        <p:style>
+          <a:lnRef idx="1">
+            <a:schemeClr val="accent1"/>
+          </a:lnRef>
+          <a:fillRef idx="3">
+            <a:schemeClr val="accent1"/>
+          </a:fillRef>
+          <a:effectRef idx="2">
+            <a:schemeClr val="accent1"/>
+          </a:effectRef>
+          <a:fontRef idx="minor">
+            <a:schemeClr val="lt1"/>
+          </a:fontRef>
+        </p:style>
+        <p:txBody>
+          <a:bodyPr rtlCol="0" anchor="ctr"/>
+          <a:lstStyle/>
+          <a:p>
+            <a:pPr algn="ctr"/>
+          </a:p>
+        </p:txBody>
+      </p:sp>
+      <p:sp>
+        <p:nvSpPr>
+          <p:cNvPr id="9" name="Rounded Rectangle 8"/>
+          <p:cNvSpPr/>
+          <p:nvPr/>
+        </p:nvSpPr>
+        <p:spPr>
+          <a:xfrm>
+            <a:off x="5065776" y="1828800"/>
+            <a:ext cx="2103120" cy="2103120"/>
           </a:xfrm>
           <a:prstGeom prst="roundRect">
             <a:avLst/>
@@ -8520,13 +8719,13 @@
               </a:spcAft>
             </a:pPr>
             <a:r>
-              <a:rPr sz="1300" b="1" i="0">
-                <a:solidFill>
-                  <a:srgbClr val="3BB33B"/>
-                </a:solidFill>
-                <a:latin typeface="Montserrat"/>
-              </a:rPr>
-              <a:t>GOVERNANÇA E ACCOUNTABILITY</a:t>
+              <a:rPr sz="1200" b="1" i="0">
+                <a:solidFill>
+                  <a:srgbClr val="F97316"/>
+                </a:solidFill>
+                <a:latin typeface="Montserrat"/>
+              </a:rPr>
+              <a:t>3 · TRATAMENTO</a:t>
             </a:r>
           </a:p>
           <a:p>
@@ -8542,37 +8741,64 @@
                 </a:solidFill>
                 <a:latin typeface="Montserrat"/>
               </a:rPr>
-              <a:t>Cada desvio com dono, prazo e status;</a:t>
-            </a:r>
-          </a:p>
-          <a:p>
-            <a:pPr>
-              <a:spcAft>
-                <a:spcPts val="200"/>
-              </a:spcAft>
-            </a:pPr>
-            <a:r>
-              <a:rPr sz="1100" b="0" i="0">
-                <a:solidFill>
-                  <a:srgbClr val="94A3B8"/>
-                </a:solidFill>
-                <a:latin typeface="Montserrat"/>
-              </a:rPr>
-              <a:t>aderência medida; ranking dá consequência</a:t>
-            </a:r>
-          </a:p>
-        </p:txBody>
-      </p:sp>
-      <p:sp>
-        <p:nvSpPr>
-          <p:cNvPr id="8" name="Rounded Rectangle 7"/>
+              <a:t>Cada unidade preenche causa, ação, responsável e prazo</a:t>
+            </a:r>
+          </a:p>
+        </p:txBody>
+      </p:sp>
+      <p:sp>
+        <p:nvSpPr>
+          <p:cNvPr id="10" name="Right Arrow 9"/>
           <p:cNvSpPr/>
           <p:nvPr/>
         </p:nvSpPr>
         <p:spPr>
           <a:xfrm>
-            <a:off x="6217920" y="3154680"/>
-            <a:ext cx="5394960" cy="1417320"/>
+            <a:off x="7187184" y="2697480"/>
+            <a:ext cx="219456" cy="292608"/>
+          </a:xfrm>
+          <a:prstGeom prst="rightArrow">
+            <a:avLst/>
+          </a:prstGeom>
+          <a:solidFill>
+            <a:srgbClr val="F97316"/>
+          </a:solidFill>
+          <a:ln>
+            <a:noFill/>
+          </a:ln>
+        </p:spPr>
+        <p:style>
+          <a:lnRef idx="1">
+            <a:schemeClr val="accent1"/>
+          </a:lnRef>
+          <a:fillRef idx="3">
+            <a:schemeClr val="accent1"/>
+          </a:fillRef>
+          <a:effectRef idx="2">
+            <a:schemeClr val="accent1"/>
+          </a:effectRef>
+          <a:fontRef idx="minor">
+            <a:schemeClr val="lt1"/>
+          </a:fontRef>
+        </p:style>
+        <p:txBody>
+          <a:bodyPr rtlCol="0" anchor="ctr"/>
+          <a:lstStyle/>
+          <a:p>
+            <a:pPr algn="ctr"/>
+          </a:p>
+        </p:txBody>
+      </p:sp>
+      <p:sp>
+        <p:nvSpPr>
+          <p:cNvPr id="11" name="Rounded Rectangle 10"/>
+          <p:cNvSpPr/>
+          <p:nvPr/>
+        </p:nvSpPr>
+        <p:spPr>
+          <a:xfrm>
+            <a:off x="7324344" y="1828800"/>
+            <a:ext cx="2103120" cy="2103120"/>
           </a:xfrm>
           <a:prstGeom prst="roundRect">
             <a:avLst/>
@@ -8610,13 +8836,13 @@
               </a:spcAft>
             </a:pPr>
             <a:r>
-              <a:rPr sz="1300" b="1" i="0">
-                <a:solidFill>
-                  <a:srgbClr val="3BB33B"/>
-                </a:solidFill>
-                <a:latin typeface="Montserrat"/>
-              </a:rPr>
-              <a:t>AGILIDADE</a:t>
+              <a:rPr sz="1200" b="1" i="0">
+                <a:solidFill>
+                  <a:srgbClr val="F97316"/>
+                </a:solidFill>
+                <a:latin typeface="Montserrat"/>
+              </a:rPr>
+              <a:t>4 · REUNIÃO (MPR)</a:t>
             </a:r>
           </a:p>
           <a:p>
@@ -8632,7 +8858,108 @@
                 </a:solidFill>
                 <a:latin typeface="Montserrat"/>
               </a:rPr>
-              <a:t>Dados ao abrir a página (sem espera de carga);</a:t>
+              <a:t>Resultados e planos revisados na mesa mensal</a:t>
+            </a:r>
+          </a:p>
+        </p:txBody>
+      </p:sp>
+      <p:sp>
+        <p:nvSpPr>
+          <p:cNvPr id="12" name="Right Arrow 11"/>
+          <p:cNvSpPr/>
+          <p:nvPr/>
+        </p:nvSpPr>
+        <p:spPr>
+          <a:xfrm>
+            <a:off x="9445752" y="2697480"/>
+            <a:ext cx="219456" cy="292608"/>
+          </a:xfrm>
+          <a:prstGeom prst="rightArrow">
+            <a:avLst/>
+          </a:prstGeom>
+          <a:solidFill>
+            <a:srgbClr val="F97316"/>
+          </a:solidFill>
+          <a:ln>
+            <a:noFill/>
+          </a:ln>
+        </p:spPr>
+        <p:style>
+          <a:lnRef idx="1">
+            <a:schemeClr val="accent1"/>
+          </a:lnRef>
+          <a:fillRef idx="3">
+            <a:schemeClr val="accent1"/>
+          </a:fillRef>
+          <a:effectRef idx="2">
+            <a:schemeClr val="accent1"/>
+          </a:effectRef>
+          <a:fontRef idx="minor">
+            <a:schemeClr val="lt1"/>
+          </a:fontRef>
+        </p:style>
+        <p:txBody>
+          <a:bodyPr rtlCol="0" anchor="ctr"/>
+          <a:lstStyle/>
+          <a:p>
+            <a:pPr algn="ctr"/>
+          </a:p>
+        </p:txBody>
+      </p:sp>
+      <p:sp>
+        <p:nvSpPr>
+          <p:cNvPr id="13" name="Rounded Rectangle 12"/>
+          <p:cNvSpPr/>
+          <p:nvPr/>
+        </p:nvSpPr>
+        <p:spPr>
+          <a:xfrm>
+            <a:off x="9582912" y="1828800"/>
+            <a:ext cx="2103120" cy="2103120"/>
+          </a:xfrm>
+          <a:prstGeom prst="roundRect">
+            <a:avLst/>
+          </a:prstGeom>
+          <a:solidFill>
+            <a:srgbClr val="141B26"/>
+          </a:solidFill>
+          <a:ln w="12700">
+            <a:solidFill>
+              <a:srgbClr val="1E2D40"/>
+            </a:solidFill>
+          </a:ln>
+        </p:spPr>
+        <p:style>
+          <a:lnRef idx="1">
+            <a:schemeClr val="accent1"/>
+          </a:lnRef>
+          <a:fillRef idx="3">
+            <a:schemeClr val="accent1"/>
+          </a:fillRef>
+          <a:effectRef idx="2">
+            <a:schemeClr val="accent1"/>
+          </a:effectRef>
+          <a:fontRef idx="minor">
+            <a:schemeClr val="lt1"/>
+          </a:fontRef>
+        </p:style>
+        <p:txBody>
+          <a:bodyPr rtlCol="0" anchor="t" wrap="square" lIns="146304" rIns="128016" tIns="91440" bIns="73152"/>
+          <a:lstStyle/>
+          <a:p>
+            <a:pPr algn="ctr">
+              <a:spcAft>
+                <a:spcPts val="400"/>
+              </a:spcAft>
+            </a:pPr>
+            <a:r>
+              <a:rPr sz="1200" b="1" i="0">
+                <a:solidFill>
+                  <a:srgbClr val="F97316"/>
+                </a:solidFill>
+                <a:latin typeface="Montserrat"/>
+              </a:rPr>
+              <a:t>5 · ACOMPANHAMENTO</a:t>
             </a:r>
           </a:p>
           <a:p>
@@ -8648,21 +8975,21 @@
                 </a:solidFill>
                 <a:latin typeface="Montserrat"/>
               </a:rPr>
-              <a:t>novos painéis em dias, sem depender de fornecedor</a:t>
-            </a:r>
-          </a:p>
-        </p:txBody>
-      </p:sp>
-      <p:sp>
-        <p:nvSpPr>
-          <p:cNvPr id="9" name="TextBox 8"/>
+              <a:t>Aderência, kanban e termômetro até o próximo ciclo</a:t>
+            </a:r>
+          </a:p>
+        </p:txBody>
+      </p:sp>
+      <p:sp>
+        <p:nvSpPr>
+          <p:cNvPr id="14" name="TextBox 13"/>
           <p:cNvSpPr txBox="1"/>
           <p:nvPr/>
         </p:nvSpPr>
         <p:spPr>
           <a:xfrm>
-            <a:off x="548640" y="4892040"/>
-            <a:ext cx="11064240" cy="1097280"/>
+            <a:off x="548640" y="4389120"/>
+            <a:ext cx="11064240" cy="1280160"/>
           </a:xfrm>
           <a:prstGeom prst="rect">
             <a:avLst/>
@@ -8678,18 +9005,18 @@
             <a:r>
               <a:rPr sz="1400" b="1" i="0">
                 <a:solidFill>
-                  <a:srgbClr val="F97316"/>
-                </a:solidFill>
-                <a:latin typeface="Montserrat"/>
-              </a:rPr>
-              <a:t>Substituição completa do Looker Studio concluída — com mais funcionalidades (preenchimento, kanban, travas, perfis).</a:t>
-            </a:r>
-          </a:p>
-        </p:txBody>
-      </p:sp>
-      <p:sp>
-        <p:nvSpPr>
-          <p:cNvPr id="10" name="TextBox 9"/>
+                  <a:srgbClr val="94A3B8"/>
+                </a:solidFill>
+                <a:latin typeface="Montserrat"/>
+              </a:rPr>
+              <a:t>Sem carga manual de dados, sem consolidação em Excel: o portal lê as fontes e conduz o processo.</a:t>
+            </a:r>
+          </a:p>
+        </p:txBody>
+      </p:sp>
+      <p:sp>
+        <p:nvSpPr>
+          <p:cNvPr id="15" name="TextBox 14"/>
           <p:cNvSpPr txBox="1"/>
           <p:nvPr/>
         </p:nvSpPr>

</xml_diff>

<commit_message>
Docs TI: atualiza documentação técnica e decks com Farol Frota, Acessos e Recebe Farol (#51)
- DOCUMENTACAO-TI.md: nova seção Farol Frota (fontes, seções, envio por e-mail), painel Acessos + access_log, coluna farol_unidades, farol-mailer/workflow, diagrama e rotina atualizados
- docs/*.pptx: decks técnico (18 slides) e business (13) regenerados com Farol e Acessos


Claude-Session: https://claude.ai/code/session_01CoPzrx19nUHZqody5fEJUg

Co-authored-by: Claude <noreply@anthropic.com>
</commit_message>
<xml_diff>
--- a/docs/Gestao-em-Movimento_Business.pptx
+++ b/docs/Gestao-em-Movimento_Business.pptx
@@ -17,6 +17,7 @@
     <p:sldId id="265" r:id="rId16"/>
     <p:sldId id="266" r:id="rId17"/>
     <p:sldId id="267" r:id="rId18"/>
+    <p:sldId id="268" r:id="rId19"/>
   </p:sldIdLst>
   <p:sldSz cx="12191695" cy="6858000" type="screen4x3"/>
   <p:notesSz cx="6858000" cy="9144000"/>
@@ -3426,21 +3427,381 @@
                 </a:solidFill>
                 <a:latin typeface="Montserrat"/>
               </a:rPr>
-              <a:t>Acesso e governança</a:t>
-            </a:r>
-          </a:p>
-        </p:txBody>
-      </p:sp>
-      <p:sp>
-        <p:nvSpPr>
-          <p:cNvPr id="5" name="TextBox 4"/>
+              <a:t>Benefícios</a:t>
+            </a:r>
+          </a:p>
+        </p:txBody>
+      </p:sp>
+      <p:sp>
+        <p:nvSpPr>
+          <p:cNvPr id="5" name="Rounded Rectangle 4"/>
+          <p:cNvSpPr/>
+          <p:nvPr/>
+        </p:nvSpPr>
+        <p:spPr>
+          <a:xfrm>
+            <a:off x="548640" y="1554480"/>
+            <a:ext cx="5394960" cy="1417320"/>
+          </a:xfrm>
+          <a:prstGeom prst="roundRect">
+            <a:avLst/>
+          </a:prstGeom>
+          <a:solidFill>
+            <a:srgbClr val="141B26"/>
+          </a:solidFill>
+          <a:ln w="12700">
+            <a:solidFill>
+              <a:srgbClr val="1E2D40"/>
+            </a:solidFill>
+          </a:ln>
+        </p:spPr>
+        <p:style>
+          <a:lnRef idx="1">
+            <a:schemeClr val="accent1"/>
+          </a:lnRef>
+          <a:fillRef idx="3">
+            <a:schemeClr val="accent1"/>
+          </a:fillRef>
+          <a:effectRef idx="2">
+            <a:schemeClr val="accent1"/>
+          </a:effectRef>
+          <a:fontRef idx="minor">
+            <a:schemeClr val="lt1"/>
+          </a:fontRef>
+        </p:style>
+        <p:txBody>
+          <a:bodyPr rtlCol="0" anchor="t" wrap="square" lIns="146304" rIns="128016" tIns="91440" bIns="73152"/>
+          <a:lstStyle/>
+          <a:p>
+            <a:pPr algn="ctr">
+              <a:spcAft>
+                <a:spcPts val="400"/>
+              </a:spcAft>
+            </a:pPr>
+            <a:r>
+              <a:rPr sz="1300" b="1" i="0">
+                <a:solidFill>
+                  <a:srgbClr val="3BB33B"/>
+                </a:solidFill>
+                <a:latin typeface="Montserrat"/>
+              </a:rPr>
+              <a:t>CUSTO ≈ ZERO DE INFRAESTRUTURA</a:t>
+            </a:r>
+          </a:p>
+          <a:p>
+            <a:pPr>
+              <a:spcAft>
+                <a:spcPts val="200"/>
+              </a:spcAft>
+            </a:pPr>
+            <a:r>
+              <a:rPr sz="1100" b="0" i="0">
+                <a:solidFill>
+                  <a:srgbClr val="94A3B8"/>
+                </a:solidFill>
+                <a:latin typeface="Montserrat"/>
+              </a:rPr>
+              <a:t>Hospedagem e automações em camadas gratuitas;</a:t>
+            </a:r>
+          </a:p>
+          <a:p>
+            <a:pPr>
+              <a:spcAft>
+                <a:spcPts val="200"/>
+              </a:spcAft>
+            </a:pPr>
+            <a:r>
+              <a:rPr sz="1100" b="0" i="0">
+                <a:solidFill>
+                  <a:srgbClr val="94A3B8"/>
+                </a:solidFill>
+                <a:latin typeface="Montserrat"/>
+              </a:rPr>
+              <a:t>sem licença por usuário (vs. ferramenta paga de BI)</a:t>
+            </a:r>
+          </a:p>
+        </p:txBody>
+      </p:sp>
+      <p:sp>
+        <p:nvSpPr>
+          <p:cNvPr id="6" name="Rounded Rectangle 5"/>
+          <p:cNvSpPr/>
+          <p:nvPr/>
+        </p:nvSpPr>
+        <p:spPr>
+          <a:xfrm>
+            <a:off x="6217920" y="1554480"/>
+            <a:ext cx="5394960" cy="1417320"/>
+          </a:xfrm>
+          <a:prstGeom prst="roundRect">
+            <a:avLst/>
+          </a:prstGeom>
+          <a:solidFill>
+            <a:srgbClr val="141B26"/>
+          </a:solidFill>
+          <a:ln w="12700">
+            <a:solidFill>
+              <a:srgbClr val="1E2D40"/>
+            </a:solidFill>
+          </a:ln>
+        </p:spPr>
+        <p:style>
+          <a:lnRef idx="1">
+            <a:schemeClr val="accent1"/>
+          </a:lnRef>
+          <a:fillRef idx="3">
+            <a:schemeClr val="accent1"/>
+          </a:fillRef>
+          <a:effectRef idx="2">
+            <a:schemeClr val="accent1"/>
+          </a:effectRef>
+          <a:fontRef idx="minor">
+            <a:schemeClr val="lt1"/>
+          </a:fontRef>
+        </p:style>
+        <p:txBody>
+          <a:bodyPr rtlCol="0" anchor="t" wrap="square" lIns="146304" rIns="128016" tIns="91440" bIns="73152"/>
+          <a:lstStyle/>
+          <a:p>
+            <a:pPr algn="ctr">
+              <a:spcAft>
+                <a:spcPts val="400"/>
+              </a:spcAft>
+            </a:pPr>
+            <a:r>
+              <a:rPr sz="1300" b="1" i="0">
+                <a:solidFill>
+                  <a:srgbClr val="3BB33B"/>
+                </a:solidFill>
+                <a:latin typeface="Montserrat"/>
+              </a:rPr>
+              <a:t>FONTE ÚNICA DA VERDADE</a:t>
+            </a:r>
+          </a:p>
+          <a:p>
+            <a:pPr>
+              <a:spcAft>
+                <a:spcPts val="200"/>
+              </a:spcAft>
+            </a:pPr>
+            <a:r>
+              <a:rPr sz="1100" b="0" i="0">
+                <a:solidFill>
+                  <a:srgbClr val="94A3B8"/>
+                </a:solidFill>
+                <a:latin typeface="Montserrat"/>
+              </a:rPr>
+              <a:t>Mesmo número em todos os painéis;</a:t>
+            </a:r>
+          </a:p>
+          <a:p>
+            <a:pPr>
+              <a:spcAft>
+                <a:spcPts val="200"/>
+              </a:spcAft>
+            </a:pPr>
+            <a:r>
+              <a:rPr sz="1100" b="0" i="0">
+                <a:solidFill>
+                  <a:srgbClr val="94A3B8"/>
+                </a:solidFill>
+                <a:latin typeface="Montserrat"/>
+              </a:rPr>
+              <a:t>planos de ação centralizados e auditáveis na nuvem</a:t>
+            </a:r>
+          </a:p>
+        </p:txBody>
+      </p:sp>
+      <p:sp>
+        <p:nvSpPr>
+          <p:cNvPr id="7" name="Rounded Rectangle 6"/>
+          <p:cNvSpPr/>
+          <p:nvPr/>
+        </p:nvSpPr>
+        <p:spPr>
+          <a:xfrm>
+            <a:off x="548640" y="3154680"/>
+            <a:ext cx="5394960" cy="1417320"/>
+          </a:xfrm>
+          <a:prstGeom prst="roundRect">
+            <a:avLst/>
+          </a:prstGeom>
+          <a:solidFill>
+            <a:srgbClr val="141B26"/>
+          </a:solidFill>
+          <a:ln w="12700">
+            <a:solidFill>
+              <a:srgbClr val="1E2D40"/>
+            </a:solidFill>
+          </a:ln>
+        </p:spPr>
+        <p:style>
+          <a:lnRef idx="1">
+            <a:schemeClr val="accent1"/>
+          </a:lnRef>
+          <a:fillRef idx="3">
+            <a:schemeClr val="accent1"/>
+          </a:fillRef>
+          <a:effectRef idx="2">
+            <a:schemeClr val="accent1"/>
+          </a:effectRef>
+          <a:fontRef idx="minor">
+            <a:schemeClr val="lt1"/>
+          </a:fontRef>
+        </p:style>
+        <p:txBody>
+          <a:bodyPr rtlCol="0" anchor="t" wrap="square" lIns="146304" rIns="128016" tIns="91440" bIns="73152"/>
+          <a:lstStyle/>
+          <a:p>
+            <a:pPr algn="ctr">
+              <a:spcAft>
+                <a:spcPts val="400"/>
+              </a:spcAft>
+            </a:pPr>
+            <a:r>
+              <a:rPr sz="1300" b="1" i="0">
+                <a:solidFill>
+                  <a:srgbClr val="3BB33B"/>
+                </a:solidFill>
+                <a:latin typeface="Montserrat"/>
+              </a:rPr>
+              <a:t>GOVERNANÇA E ACCOUNTABILITY</a:t>
+            </a:r>
+          </a:p>
+          <a:p>
+            <a:pPr>
+              <a:spcAft>
+                <a:spcPts val="200"/>
+              </a:spcAft>
+            </a:pPr>
+            <a:r>
+              <a:rPr sz="1100" b="0" i="0">
+                <a:solidFill>
+                  <a:srgbClr val="94A3B8"/>
+                </a:solidFill>
+                <a:latin typeface="Montserrat"/>
+              </a:rPr>
+              <a:t>Cada desvio com dono, prazo e status;</a:t>
+            </a:r>
+          </a:p>
+          <a:p>
+            <a:pPr>
+              <a:spcAft>
+                <a:spcPts val="200"/>
+              </a:spcAft>
+            </a:pPr>
+            <a:r>
+              <a:rPr sz="1100" b="0" i="0">
+                <a:solidFill>
+                  <a:srgbClr val="94A3B8"/>
+                </a:solidFill>
+                <a:latin typeface="Montserrat"/>
+              </a:rPr>
+              <a:t>aderência medida; ranking dá consequência</a:t>
+            </a:r>
+          </a:p>
+        </p:txBody>
+      </p:sp>
+      <p:sp>
+        <p:nvSpPr>
+          <p:cNvPr id="8" name="Rounded Rectangle 7"/>
+          <p:cNvSpPr/>
+          <p:nvPr/>
+        </p:nvSpPr>
+        <p:spPr>
+          <a:xfrm>
+            <a:off x="6217920" y="3154680"/>
+            <a:ext cx="5394960" cy="1417320"/>
+          </a:xfrm>
+          <a:prstGeom prst="roundRect">
+            <a:avLst/>
+          </a:prstGeom>
+          <a:solidFill>
+            <a:srgbClr val="141B26"/>
+          </a:solidFill>
+          <a:ln w="12700">
+            <a:solidFill>
+              <a:srgbClr val="1E2D40"/>
+            </a:solidFill>
+          </a:ln>
+        </p:spPr>
+        <p:style>
+          <a:lnRef idx="1">
+            <a:schemeClr val="accent1"/>
+          </a:lnRef>
+          <a:fillRef idx="3">
+            <a:schemeClr val="accent1"/>
+          </a:fillRef>
+          <a:effectRef idx="2">
+            <a:schemeClr val="accent1"/>
+          </a:effectRef>
+          <a:fontRef idx="minor">
+            <a:schemeClr val="lt1"/>
+          </a:fontRef>
+        </p:style>
+        <p:txBody>
+          <a:bodyPr rtlCol="0" anchor="t" wrap="square" lIns="146304" rIns="128016" tIns="91440" bIns="73152"/>
+          <a:lstStyle/>
+          <a:p>
+            <a:pPr algn="ctr">
+              <a:spcAft>
+                <a:spcPts val="400"/>
+              </a:spcAft>
+            </a:pPr>
+            <a:r>
+              <a:rPr sz="1300" b="1" i="0">
+                <a:solidFill>
+                  <a:srgbClr val="3BB33B"/>
+                </a:solidFill>
+                <a:latin typeface="Montserrat"/>
+              </a:rPr>
+              <a:t>AGILIDADE</a:t>
+            </a:r>
+          </a:p>
+          <a:p>
+            <a:pPr>
+              <a:spcAft>
+                <a:spcPts val="200"/>
+              </a:spcAft>
+            </a:pPr>
+            <a:r>
+              <a:rPr sz="1100" b="0" i="0">
+                <a:solidFill>
+                  <a:srgbClr val="94A3B8"/>
+                </a:solidFill>
+                <a:latin typeface="Montserrat"/>
+              </a:rPr>
+              <a:t>Dados ao abrir a página (sem espera de carga);</a:t>
+            </a:r>
+          </a:p>
+          <a:p>
+            <a:pPr>
+              <a:spcAft>
+                <a:spcPts val="200"/>
+              </a:spcAft>
+            </a:pPr>
+            <a:r>
+              <a:rPr sz="1100" b="0" i="0">
+                <a:solidFill>
+                  <a:srgbClr val="94A3B8"/>
+                </a:solidFill>
+                <a:latin typeface="Montserrat"/>
+              </a:rPr>
+              <a:t>novos painéis em dias, sem depender de fornecedor</a:t>
+            </a:r>
+          </a:p>
+        </p:txBody>
+      </p:sp>
+      <p:sp>
+        <p:nvSpPr>
+          <p:cNvPr id="9" name="TextBox 8"/>
           <p:cNvSpPr txBox="1"/>
           <p:nvPr/>
         </p:nvSpPr>
         <p:spPr>
           <a:xfrm>
-            <a:off x="548640" y="1417320"/>
-            <a:ext cx="11064240" cy="5120640"/>
+            <a:off x="548640" y="4892040"/>
+            <a:ext cx="11064240" cy="1097280"/>
           </a:xfrm>
           <a:prstGeom prst="rect">
             <a:avLst/>
@@ -3453,135 +3814,21 @@
           </a:bodyPr>
           <a:lstStyle/>
           <a:p>
-            <a:pPr>
-              <a:spcAft>
-                <a:spcPts val="700"/>
-              </a:spcAft>
-            </a:pPr>
-            <a:r>
-              <a:rPr sz="1600" b="1" i="0">
+            <a:r>
+              <a:rPr sz="1400" b="1" i="0">
                 <a:solidFill>
                   <a:srgbClr val="F97316"/>
                 </a:solidFill>
                 <a:latin typeface="Montserrat"/>
               </a:rPr>
-              <a:t>▪  </a:t>
-            </a:r>
-            <a:r>
-              <a:rPr sz="1600" b="0" i="0">
-                <a:solidFill>
-                  <a:srgbClr val="F1F5F9"/>
-                </a:solidFill>
-                <a:latin typeface="Montserrat"/>
-              </a:rPr>
-              <a:t>Login individual (e-mail corporativo) com confirmação; recuperação de senha automática.</a:t>
-            </a:r>
-          </a:p>
-          <a:p>
-            <a:pPr>
-              <a:spcAft>
-                <a:spcPts val="700"/>
-              </a:spcAft>
-            </a:pPr>
-            <a:r>
-              <a:rPr sz="1600" b="1" i="0">
-                <a:solidFill>
-                  <a:srgbClr val="F97316"/>
-                </a:solidFill>
-                <a:latin typeface="Montserrat"/>
-              </a:rPr>
-              <a:t>▪  </a:t>
-            </a:r>
-            <a:r>
-              <a:rPr sz="1600" b="0" i="0">
-                <a:solidFill>
-                  <a:srgbClr val="F1F5F9"/>
-                </a:solidFill>
-                <a:latin typeface="Montserrat"/>
-              </a:rPr>
-              <a:t>Perfil por unidade: o gestor de CGR só enxerga e edita CGR; admin enxerga tudo.</a:t>
-            </a:r>
-          </a:p>
-          <a:p>
-            <a:pPr>
-              <a:spcAft>
-                <a:spcPts val="700"/>
-              </a:spcAft>
-            </a:pPr>
-            <a:r>
-              <a:rPr sz="1600" b="1" i="0">
-                <a:solidFill>
-                  <a:srgbClr val="F97316"/>
-                </a:solidFill>
-                <a:latin typeface="Montserrat"/>
-              </a:rPr>
-              <a:t>▪  </a:t>
-            </a:r>
-            <a:r>
-              <a:rPr sz="1600" b="0" i="0">
-                <a:solidFill>
-                  <a:srgbClr val="F1F5F9"/>
-                </a:solidFill>
-                <a:latin typeface="Montserrat"/>
-              </a:rPr>
-              <a:t>Aprovação de novos usuários centralizada no card “Gerenciar Acessos” (admin).</a:t>
-            </a:r>
-          </a:p>
-          <a:p>
-            <a:pPr>
-              <a:spcAft>
-                <a:spcPts val="700"/>
-              </a:spcAft>
-            </a:pPr>
-            <a:r>
-              <a:rPr sz="1600" b="1" i="0">
-                <a:solidFill>
-                  <a:srgbClr val="F97316"/>
-                </a:solidFill>
-                <a:latin typeface="Montserrat"/>
-              </a:rPr>
-              <a:t>▪  </a:t>
-            </a:r>
-            <a:r>
-              <a:rPr sz="1600" b="0" i="0">
-                <a:solidFill>
-                  <a:srgbClr val="F1F5F9"/>
-                </a:solidFill>
-                <a:latin typeface="Montserrat"/>
-              </a:rPr>
-              <a:t>Ações do FCA travadas após salvar — histórico não pode ser reescrito (só acompanhamento evolui).</a:t>
-            </a:r>
-          </a:p>
-          <a:p>
-            <a:pPr>
-              <a:spcAft>
-                <a:spcPts val="700"/>
-              </a:spcAft>
-            </a:pPr>
-            <a:r>
-              <a:rPr sz="1600" b="1" i="0">
-                <a:solidFill>
-                  <a:srgbClr val="F97316"/>
-                </a:solidFill>
-                <a:latin typeface="Montserrat"/>
-              </a:rPr>
-              <a:t>▪  </a:t>
-            </a:r>
-            <a:r>
-              <a:rPr sz="1600" b="0" i="0">
-                <a:solidFill>
-                  <a:srgbClr val="F1F5F9"/>
-                </a:solidFill>
-                <a:latin typeface="Montserrat"/>
-              </a:rPr>
-              <a:t>Todo o código versionado (GitHub) — cada mudança tem autor, data e histórico completo.</a:t>
-            </a:r>
-          </a:p>
-        </p:txBody>
-      </p:sp>
-      <p:sp>
-        <p:nvSpPr>
-          <p:cNvPr id="6" name="TextBox 5"/>
+              <a:t>Substituição completa do Looker Studio concluída — com mais funcionalidades (preenchimento, kanban, travas, perfis).</a:t>
+            </a:r>
+          </a:p>
+        </p:txBody>
+      </p:sp>
+      <p:sp>
+        <p:nvSpPr>
+          <p:cNvPr id="10" name="TextBox 9"/>
           <p:cNvSpPr txBox="1"/>
           <p:nvPr/>
         </p:nvSpPr>
@@ -3766,7 +4013,7 @@
                 </a:solidFill>
                 <a:latin typeface="Montserrat"/>
               </a:rPr>
-              <a:t>Roadmap sugerido</a:t>
+              <a:t>Acesso e governança</a:t>
             </a:r>
           </a:p>
         </p:txBody>
@@ -3799,7 +4046,7 @@
               </a:spcAft>
             </a:pPr>
             <a:r>
-              <a:rPr sz="1500" b="1" i="0">
+              <a:rPr sz="1600" b="1" i="0">
                 <a:solidFill>
                   <a:srgbClr val="F97316"/>
                 </a:solidFill>
@@ -3808,238 +4055,113 @@
               <a:t>▪  </a:t>
             </a:r>
             <a:r>
-              <a:rPr sz="1500" b="1" i="0">
+              <a:rPr sz="1600" b="0" i="0">
+                <a:solidFill>
+                  <a:srgbClr val="F1F5F9"/>
+                </a:solidFill>
+                <a:latin typeface="Montserrat"/>
+              </a:rPr>
+              <a:t>Login individual (e-mail corporativo) com confirmação; recuperação de senha automática.</a:t>
+            </a:r>
+          </a:p>
+          <a:p>
+            <a:pPr>
+              <a:spcAft>
+                <a:spcPts val="700"/>
+              </a:spcAft>
+            </a:pPr>
+            <a:r>
+              <a:rPr sz="1600" b="1" i="0">
                 <a:solidFill>
                   <a:srgbClr val="F97316"/>
                 </a:solidFill>
                 <a:latin typeface="Montserrat"/>
               </a:rPr>
-              <a:t>Curto prazo:</a:t>
+              <a:t>▪  </a:t>
+            </a:r>
+            <a:r>
+              <a:rPr sz="1600" b="0" i="0">
+                <a:solidFill>
+                  <a:srgbClr val="F1F5F9"/>
+                </a:solidFill>
+                <a:latin typeface="Montserrat"/>
+              </a:rPr>
+              <a:t>Perfil por unidade: o gestor de CGR só enxerga e edita CGR; admin enxerga tudo.</a:t>
             </a:r>
           </a:p>
           <a:p>
             <a:pPr>
               <a:spcAft>
-                <a:spcPts val="400"/>
-              </a:spcAft>
-            </a:pPr>
-            <a:r>
-              <a:rPr sz="1350" b="1" i="0">
-                <a:solidFill>
-                  <a:srgbClr val="64748B"/>
-                </a:solidFill>
-                <a:latin typeface="Montserrat"/>
-              </a:rPr>
-              <a:t>      –  </a:t>
-            </a:r>
-            <a:r>
-              <a:rPr sz="1350" b="0" i="0">
+                <a:spcPts val="700"/>
+              </a:spcAft>
+            </a:pPr>
+            <a:r>
+              <a:rPr sz="1600" b="1" i="0">
+                <a:solidFill>
+                  <a:srgbClr val="F97316"/>
+                </a:solidFill>
+                <a:latin typeface="Montserrat"/>
+              </a:rPr>
+              <a:t>▪  </a:t>
+            </a:r>
+            <a:r>
+              <a:rPr sz="1600" b="0" i="0">
                 <a:solidFill>
                   <a:srgbClr val="F1F5F9"/>
                 </a:solidFill>
                 <a:latin typeface="Montserrat"/>
               </a:rPr>
-              <a:t>Mover os campos do MPR para a nuvem (hoje ficam no navegador de quem digita)</a:t>
+              <a:t>Aprovação de novos usuários centralizada no card “Gerenciar Acessos” (admin).</a:t>
             </a:r>
           </a:p>
           <a:p>
             <a:pPr>
               <a:spcAft>
-                <a:spcPts val="400"/>
-              </a:spcAft>
-            </a:pPr>
-            <a:r>
-              <a:rPr sz="1350" b="1" i="0">
-                <a:solidFill>
-                  <a:srgbClr val="64748B"/>
-                </a:solidFill>
-                <a:latin typeface="Montserrat"/>
-              </a:rPr>
-              <a:t>      –  </a:t>
-            </a:r>
-            <a:r>
-              <a:rPr sz="1350" b="0" i="0">
+                <a:spcPts val="700"/>
+              </a:spcAft>
+            </a:pPr>
+            <a:r>
+              <a:rPr sz="1600" b="1" i="0">
+                <a:solidFill>
+                  <a:srgbClr val="F97316"/>
+                </a:solidFill>
+                <a:latin typeface="Montserrat"/>
+              </a:rPr>
+              <a:t>▪  </a:t>
+            </a:r>
+            <a:r>
+              <a:rPr sz="1600" b="0" i="0">
                 <a:solidFill>
                   <a:srgbClr val="F1F5F9"/>
                 </a:solidFill>
                 <a:latin typeface="Montserrat"/>
               </a:rPr>
-              <a:t>Aviso de “alterações não salvas” no FCA Preenchimento</a:t>
+              <a:t>Ações do FCA travadas após salvar — histórico não pode ser reescrito (só acompanhamento evolui).</a:t>
             </a:r>
           </a:p>
           <a:p>
             <a:pPr>
               <a:spcAft>
-                <a:spcPts val="400"/>
-              </a:spcAft>
-            </a:pPr>
-            <a:r>
-              <a:rPr sz="1350" b="1" i="0">
-                <a:solidFill>
-                  <a:srgbClr val="64748B"/>
-                </a:solidFill>
-                <a:latin typeface="Montserrat"/>
-              </a:rPr>
-              <a:t>      –  </a:t>
-            </a:r>
-            <a:r>
-              <a:rPr sz="1350" b="0" i="0">
+                <a:spcPts val="700"/>
+              </a:spcAft>
+            </a:pPr>
+            <a:r>
+              <a:rPr sz="1600" b="1" i="0">
+                <a:solidFill>
+                  <a:srgbClr val="F97316"/>
+                </a:solidFill>
+                <a:latin typeface="Montserrat"/>
+              </a:rPr>
+              <a:t>▪  </a:t>
+            </a:r>
+            <a:r>
+              <a:rPr sz="1600" b="0" i="0">
                 <a:solidFill>
                   <a:srgbClr val="F1F5F9"/>
                 </a:solidFill>
                 <a:latin typeface="Montserrat"/>
               </a:rPr>
-              <a:t>Rotação de credencial pendente (integração Conlog) — higiene de segurança</a:t>
-            </a:r>
-          </a:p>
-          <a:p>
-            <a:pPr>
-              <a:spcAft>
-                <a:spcPts val="700"/>
-              </a:spcAft>
-            </a:pPr>
-            <a:r>
-              <a:rPr sz="1500" b="1" i="0">
-                <a:solidFill>
-                  <a:srgbClr val="F97316"/>
-                </a:solidFill>
-                <a:latin typeface="Montserrat"/>
-              </a:rPr>
-              <a:t>▪  </a:t>
-            </a:r>
-            <a:r>
-              <a:rPr sz="1500" b="1" i="0">
-                <a:solidFill>
-                  <a:srgbClr val="F97316"/>
-                </a:solidFill>
-                <a:latin typeface="Montserrat"/>
-              </a:rPr>
-              <a:t>Médio prazo:</a:t>
-            </a:r>
-          </a:p>
-          <a:p>
-            <a:pPr>
-              <a:spcAft>
-                <a:spcPts val="400"/>
-              </a:spcAft>
-            </a:pPr>
-            <a:r>
-              <a:rPr sz="1350" b="1" i="0">
-                <a:solidFill>
-                  <a:srgbClr val="64748B"/>
-                </a:solidFill>
-                <a:latin typeface="Montserrat"/>
-              </a:rPr>
-              <a:t>      –  </a:t>
-            </a:r>
-            <a:r>
-              <a:rPr sz="1350" b="0" i="0">
-                <a:solidFill>
-                  <a:srgbClr val="F1F5F9"/>
-                </a:solidFill>
-                <a:latin typeface="Montserrat"/>
-              </a:rPr>
-              <a:t>Notificações (e-mail/WhatsApp) de prazo de ação vencendo</a:t>
-            </a:r>
-          </a:p>
-          <a:p>
-            <a:pPr>
-              <a:spcAft>
-                <a:spcPts val="400"/>
-              </a:spcAft>
-            </a:pPr>
-            <a:r>
-              <a:rPr sz="1350" b="1" i="0">
-                <a:solidFill>
-                  <a:srgbClr val="64748B"/>
-                </a:solidFill>
-                <a:latin typeface="Montserrat"/>
-              </a:rPr>
-              <a:t>      –  </a:t>
-            </a:r>
-            <a:r>
-              <a:rPr sz="1350" b="0" i="0">
-                <a:solidFill>
-                  <a:srgbClr val="F1F5F9"/>
-                </a:solidFill>
-                <a:latin typeface="Montserrat"/>
-              </a:rPr>
-              <a:t>Completar painéis “Em breve” (R$/KM avançado, sub-hubs de clusters)</a:t>
-            </a:r>
-          </a:p>
-          <a:p>
-            <a:pPr>
-              <a:spcAft>
-                <a:spcPts val="400"/>
-              </a:spcAft>
-            </a:pPr>
-            <a:r>
-              <a:rPr sz="1350" b="1" i="0">
-                <a:solidFill>
-                  <a:srgbClr val="64748B"/>
-                </a:solidFill>
-                <a:latin typeface="Montserrat"/>
-              </a:rPr>
-              <a:t>      –  </a:t>
-            </a:r>
-            <a:r>
-              <a:rPr sz="1350" b="0" i="0">
-                <a:solidFill>
-                  <a:srgbClr val="F1F5F9"/>
-                </a:solidFill>
-                <a:latin typeface="Montserrat"/>
-              </a:rPr>
-              <a:t>Trilha de auditoria de edições do FCA (quem alterou o quê)</a:t>
-            </a:r>
-          </a:p>
-          <a:p>
-            <a:pPr>
-              <a:spcAft>
-                <a:spcPts val="700"/>
-              </a:spcAft>
-            </a:pPr>
-            <a:r>
-              <a:rPr sz="1500" b="1" i="0">
-                <a:solidFill>
-                  <a:srgbClr val="F97316"/>
-                </a:solidFill>
-                <a:latin typeface="Montserrat"/>
-              </a:rPr>
-              <a:t>▪  </a:t>
-            </a:r>
-            <a:r>
-              <a:rPr sz="1500" b="1" i="0">
-                <a:solidFill>
-                  <a:srgbClr val="F97316"/>
-                </a:solidFill>
-                <a:latin typeface="Montserrat"/>
-              </a:rPr>
-              <a:t>Contínuo:</a:t>
-            </a:r>
-          </a:p>
-          <a:p>
-            <a:pPr>
-              <a:spcAft>
-                <a:spcPts val="400"/>
-              </a:spcAft>
-            </a:pPr>
-            <a:r>
-              <a:rPr sz="1350" b="1" i="0">
-                <a:solidFill>
-                  <a:srgbClr val="64748B"/>
-                </a:solidFill>
-                <a:latin typeface="Montserrat"/>
-              </a:rPr>
-              <a:t>      –  </a:t>
-            </a:r>
-            <a:r>
-              <a:rPr sz="1350" b="0" i="0">
-                <a:solidFill>
-                  <a:srgbClr val="F1F5F9"/>
-                </a:solidFill>
-                <a:latin typeface="Montserrat"/>
-              </a:rPr>
-              <a:t>Absorção da manutenção pela TI com base na documentação técnica (DOCUMENTACAO-TI.md + deck técnico)</a:t>
+              <a:t>Todo o código versionado (GitHub) — cada mudança tem autor, data e histórico completo.</a:t>
             </a:r>
           </a:p>
         </p:txBody>
@@ -4113,8 +4235,51 @@
         </p:nvSpPr>
         <p:spPr>
           <a:xfrm>
-            <a:off x="548640" y="3200400"/>
-            <a:ext cx="2377440" cy="38100"/>
+            <a:off x="0" y="0"/>
+            <a:ext cx="12191695" cy="1170432"/>
+          </a:xfrm>
+          <a:prstGeom prst="rect">
+            <a:avLst/>
+          </a:prstGeom>
+          <a:solidFill>
+            <a:srgbClr val="141B26"/>
+          </a:solidFill>
+          <a:ln>
+            <a:noFill/>
+          </a:ln>
+        </p:spPr>
+        <p:style>
+          <a:lnRef idx="1">
+            <a:schemeClr val="accent1"/>
+          </a:lnRef>
+          <a:fillRef idx="3">
+            <a:schemeClr val="accent1"/>
+          </a:fillRef>
+          <a:effectRef idx="2">
+            <a:schemeClr val="accent1"/>
+          </a:effectRef>
+          <a:fontRef idx="minor">
+            <a:schemeClr val="lt1"/>
+          </a:fontRef>
+        </p:style>
+        <p:txBody>
+          <a:bodyPr rtlCol="0" anchor="ctr"/>
+          <a:lstStyle/>
+          <a:p>
+            <a:pPr algn="ctr"/>
+          </a:p>
+        </p:txBody>
+      </p:sp>
+      <p:sp>
+        <p:nvSpPr>
+          <p:cNvPr id="3" name="Rectangle 2"/>
+          <p:cNvSpPr/>
+          <p:nvPr/>
+        </p:nvSpPr>
+        <p:spPr>
+          <a:xfrm>
+            <a:off x="0" y="1170432"/>
+            <a:ext cx="12191695" cy="27940"/>
           </a:xfrm>
           <a:prstGeom prst="rect">
             <a:avLst/>
@@ -4150,14 +4315,14 @@
       </p:sp>
       <p:sp>
         <p:nvSpPr>
-          <p:cNvPr id="3" name="TextBox 2"/>
+          <p:cNvPr id="4" name="TextBox 3"/>
           <p:cNvSpPr txBox="1"/>
           <p:nvPr/>
         </p:nvSpPr>
         <p:spPr>
           <a:xfrm>
-            <a:off x="548640" y="2011680"/>
-            <a:ext cx="10972800" cy="1188720"/>
+            <a:off x="548640" y="109728"/>
+            <a:ext cx="11064240" cy="1005840"/>
           </a:xfrm>
           <a:prstGeom prst="rect">
             <a:avLst/>
@@ -4171,27 +4336,38 @@
           <a:lstStyle/>
           <a:p>
             <a:r>
-              <a:rPr sz="4000" b="1" i="0">
-                <a:solidFill>
-                  <a:srgbClr val="F1F5F9"/>
-                </a:solidFill>
-                <a:latin typeface="Montserrat"/>
-              </a:rPr>
-              <a:t>Gestão em Movimento</a:t>
-            </a:r>
-          </a:p>
-        </p:txBody>
-      </p:sp>
-      <p:sp>
-        <p:nvSpPr>
-          <p:cNvPr id="4" name="TextBox 3"/>
+              <a:rPr sz="1000" b="1" i="0">
+                <a:solidFill>
+                  <a:srgbClr val="64748B"/>
+                </a:solidFill>
+                <a:latin typeface="Montserrat"/>
+              </a:rPr>
+              <a:t>GESTÃO EM MOVIMENTO · BI FROTA</a:t>
+            </a:r>
+          </a:p>
+          <a:p>
+            <a:r>
+              <a:rPr sz="2600" b="1" i="0">
+                <a:solidFill>
+                  <a:srgbClr val="F97316"/>
+                </a:solidFill>
+                <a:latin typeface="Montserrat"/>
+              </a:rPr>
+              <a:t>Roadmap sugerido</a:t>
+            </a:r>
+          </a:p>
+        </p:txBody>
+      </p:sp>
+      <p:sp>
+        <p:nvSpPr>
+          <p:cNvPr id="5" name="TextBox 4"/>
           <p:cNvSpPr txBox="1"/>
           <p:nvPr/>
         </p:nvSpPr>
         <p:spPr>
           <a:xfrm>
-            <a:off x="548640" y="3429000"/>
-            <a:ext cx="10972800" cy="2011680"/>
+            <a:off x="548640" y="1417320"/>
+            <a:ext cx="11064240" cy="5120640"/>
           </a:xfrm>
           <a:prstGeom prst="rect">
             <a:avLst/>
@@ -4204,32 +4380,260 @@
           </a:bodyPr>
           <a:lstStyle/>
           <a:p>
-            <a:r>
-              <a:rPr sz="1800" b="0" i="0">
-                <a:solidFill>
-                  <a:srgbClr val="94A3B8"/>
-                </a:solidFill>
-                <a:latin typeface="Montserrat"/>
-              </a:rPr>
-              <a:t>Do indicador à ação — a gestão da frota inteira num só lugar.</a:t>
-            </a:r>
-          </a:p>
-          <a:p>
-            <a:r>
-              <a:rPr sz="1400" b="1" i="0">
+            <a:pPr>
+              <a:spcAft>
+                <a:spcPts val="700"/>
+              </a:spcAft>
+            </a:pPr>
+            <a:r>
+              <a:rPr sz="1500" b="1" i="0">
                 <a:solidFill>
                   <a:srgbClr val="F97316"/>
                 </a:solidFill>
                 <a:latin typeface="Montserrat"/>
               </a:rPr>
-              <a:t>fortesindicadores-byte.github.io/gestao-em-movimento</a:t>
-            </a:r>
-          </a:p>
-        </p:txBody>
-      </p:sp>
-      <p:sp>
-        <p:nvSpPr>
-          <p:cNvPr id="5" name="TextBox 4"/>
+              <a:t>▪  </a:t>
+            </a:r>
+            <a:r>
+              <a:rPr sz="1500" b="1" i="0">
+                <a:solidFill>
+                  <a:srgbClr val="F97316"/>
+                </a:solidFill>
+                <a:latin typeface="Montserrat"/>
+              </a:rPr>
+              <a:t>Curto prazo:</a:t>
+            </a:r>
+          </a:p>
+          <a:p>
+            <a:pPr>
+              <a:spcAft>
+                <a:spcPts val="400"/>
+              </a:spcAft>
+            </a:pPr>
+            <a:r>
+              <a:rPr sz="1350" b="1" i="0">
+                <a:solidFill>
+                  <a:srgbClr val="64748B"/>
+                </a:solidFill>
+                <a:latin typeface="Montserrat"/>
+              </a:rPr>
+              <a:t>      –  </a:t>
+            </a:r>
+            <a:r>
+              <a:rPr sz="1350" b="0" i="0">
+                <a:solidFill>
+                  <a:srgbClr val="F1F5F9"/>
+                </a:solidFill>
+                <a:latin typeface="Montserrat"/>
+              </a:rPr>
+              <a:t>Mover os campos do MPR para a nuvem (hoje ficam no navegador de quem digita)</a:t>
+            </a:r>
+          </a:p>
+          <a:p>
+            <a:pPr>
+              <a:spcAft>
+                <a:spcPts val="400"/>
+              </a:spcAft>
+            </a:pPr>
+            <a:r>
+              <a:rPr sz="1350" b="1" i="0">
+                <a:solidFill>
+                  <a:srgbClr val="64748B"/>
+                </a:solidFill>
+                <a:latin typeface="Montserrat"/>
+              </a:rPr>
+              <a:t>      –  </a:t>
+            </a:r>
+            <a:r>
+              <a:rPr sz="1350" b="0" i="0">
+                <a:solidFill>
+                  <a:srgbClr val="F1F5F9"/>
+                </a:solidFill>
+                <a:latin typeface="Montserrat"/>
+              </a:rPr>
+              <a:t>Aviso de “alterações não salvas” no FCA Preenchimento</a:t>
+            </a:r>
+          </a:p>
+          <a:p>
+            <a:pPr>
+              <a:spcAft>
+                <a:spcPts val="400"/>
+              </a:spcAft>
+            </a:pPr>
+            <a:r>
+              <a:rPr sz="1350" b="1" i="0">
+                <a:solidFill>
+                  <a:srgbClr val="64748B"/>
+                </a:solidFill>
+                <a:latin typeface="Montserrat"/>
+              </a:rPr>
+              <a:t>      –  </a:t>
+            </a:r>
+            <a:r>
+              <a:rPr sz="1350" b="0" i="0">
+                <a:solidFill>
+                  <a:srgbClr val="F1F5F9"/>
+                </a:solidFill>
+                <a:latin typeface="Montserrat"/>
+              </a:rPr>
+              <a:t>Rotação de credencial pendente (integração Conlog) — higiene de segurança</a:t>
+            </a:r>
+          </a:p>
+          <a:p>
+            <a:pPr>
+              <a:spcAft>
+                <a:spcPts val="700"/>
+              </a:spcAft>
+            </a:pPr>
+            <a:r>
+              <a:rPr sz="1500" b="1" i="0">
+                <a:solidFill>
+                  <a:srgbClr val="F97316"/>
+                </a:solidFill>
+                <a:latin typeface="Montserrat"/>
+              </a:rPr>
+              <a:t>▪  </a:t>
+            </a:r>
+            <a:r>
+              <a:rPr sz="1500" b="1" i="0">
+                <a:solidFill>
+                  <a:srgbClr val="F97316"/>
+                </a:solidFill>
+                <a:latin typeface="Montserrat"/>
+              </a:rPr>
+              <a:t>Médio prazo:</a:t>
+            </a:r>
+          </a:p>
+          <a:p>
+            <a:pPr>
+              <a:spcAft>
+                <a:spcPts val="400"/>
+              </a:spcAft>
+            </a:pPr>
+            <a:r>
+              <a:rPr sz="1350" b="1" i="0">
+                <a:solidFill>
+                  <a:srgbClr val="64748B"/>
+                </a:solidFill>
+                <a:latin typeface="Montserrat"/>
+              </a:rPr>
+              <a:t>      –  </a:t>
+            </a:r>
+            <a:r>
+              <a:rPr sz="1350" b="0" i="0">
+                <a:solidFill>
+                  <a:srgbClr val="F1F5F9"/>
+                </a:solidFill>
+                <a:latin typeface="Montserrat"/>
+              </a:rPr>
+              <a:t>Notificações (e-mail/WhatsApp) de prazo de ação vencendo</a:t>
+            </a:r>
+          </a:p>
+          <a:p>
+            <a:pPr>
+              <a:spcAft>
+                <a:spcPts val="400"/>
+              </a:spcAft>
+            </a:pPr>
+            <a:r>
+              <a:rPr sz="1350" b="1" i="0">
+                <a:solidFill>
+                  <a:srgbClr val="64748B"/>
+                </a:solidFill>
+                <a:latin typeface="Montserrat"/>
+              </a:rPr>
+              <a:t>      –  </a:t>
+            </a:r>
+            <a:r>
+              <a:rPr sz="1350" b="0" i="0">
+                <a:solidFill>
+                  <a:srgbClr val="F1F5F9"/>
+                </a:solidFill>
+                <a:latin typeface="Montserrat"/>
+              </a:rPr>
+              <a:t>Completar painéis “Em breve” (R$/KM avançado, sub-hubs de clusters)</a:t>
+            </a:r>
+          </a:p>
+          <a:p>
+            <a:pPr>
+              <a:spcAft>
+                <a:spcPts val="400"/>
+              </a:spcAft>
+            </a:pPr>
+            <a:r>
+              <a:rPr sz="1350" b="1" i="0">
+                <a:solidFill>
+                  <a:srgbClr val="64748B"/>
+                </a:solidFill>
+                <a:latin typeface="Montserrat"/>
+              </a:rPr>
+              <a:t>      –  </a:t>
+            </a:r>
+            <a:r>
+              <a:rPr sz="1350" b="0" i="0">
+                <a:solidFill>
+                  <a:srgbClr val="F1F5F9"/>
+                </a:solidFill>
+                <a:latin typeface="Montserrat"/>
+              </a:rPr>
+              <a:t>Trilha de auditoria de edições do FCA (quem alterou o quê)</a:t>
+            </a:r>
+          </a:p>
+          <a:p>
+            <a:pPr>
+              <a:spcAft>
+                <a:spcPts val="700"/>
+              </a:spcAft>
+            </a:pPr>
+            <a:r>
+              <a:rPr sz="1500" b="1" i="0">
+                <a:solidFill>
+                  <a:srgbClr val="F97316"/>
+                </a:solidFill>
+                <a:latin typeface="Montserrat"/>
+              </a:rPr>
+              <a:t>▪  </a:t>
+            </a:r>
+            <a:r>
+              <a:rPr sz="1500" b="1" i="0">
+                <a:solidFill>
+                  <a:srgbClr val="F97316"/>
+                </a:solidFill>
+                <a:latin typeface="Montserrat"/>
+              </a:rPr>
+              <a:t>Contínuo:</a:t>
+            </a:r>
+          </a:p>
+          <a:p>
+            <a:pPr>
+              <a:spcAft>
+                <a:spcPts val="400"/>
+              </a:spcAft>
+            </a:pPr>
+            <a:r>
+              <a:rPr sz="1350" b="1" i="0">
+                <a:solidFill>
+                  <a:srgbClr val="64748B"/>
+                </a:solidFill>
+                <a:latin typeface="Montserrat"/>
+              </a:rPr>
+              <a:t>      –  </a:t>
+            </a:r>
+            <a:r>
+              <a:rPr sz="1350" b="0" i="0">
+                <a:solidFill>
+                  <a:srgbClr val="F1F5F9"/>
+                </a:solidFill>
+                <a:latin typeface="Montserrat"/>
+              </a:rPr>
+              <a:t>Absorção da manutenção pela TI com base na documentação técnica (DOCUMENTACAO-TI.md + deck técnico)</a:t>
+            </a:r>
+          </a:p>
+        </p:txBody>
+      </p:sp>
+      <p:sp>
+        <p:nvSpPr>
+          <p:cNvPr id="6" name="TextBox 5"/>
           <p:cNvSpPr txBox="1"/>
           <p:nvPr/>
         </p:nvSpPr>
@@ -4258,6 +4662,189 @@
                 <a:latin typeface="Montserrat"/>
               </a:rPr>
               <a:t>Visão Executiva  ·  12</a:t>
+            </a:r>
+          </a:p>
+        </p:txBody>
+      </p:sp>
+    </p:spTree>
+  </p:cSld>
+  <p:clrMapOvr>
+    <a:masterClrMapping/>
+  </p:clrMapOvr>
+</p:sld>
+</file>
+
+<file path=ppt/slides/slide13.xml><?xml version="1.0" encoding="utf-8"?>
+<p:sld xmlns:a="http://schemas.openxmlformats.org/drawingml/2006/main" xmlns:p="http://schemas.openxmlformats.org/presentationml/2006/main" xmlns:r="http://schemas.openxmlformats.org/officeDocument/2006/relationships">
+  <p:cSld>
+    <p:bg>
+      <p:bgPr>
+        <a:solidFill>
+          <a:srgbClr val="0C1017"/>
+        </a:solidFill>
+        <a:effectLst/>
+      </p:bgPr>
+    </p:bg>
+    <p:spTree>
+      <p:nvGrpSpPr>
+        <p:cNvPr id="1" name=""/>
+        <p:cNvGrpSpPr/>
+        <p:nvPr/>
+      </p:nvGrpSpPr>
+      <p:grpSpPr/>
+      <p:sp>
+        <p:nvSpPr>
+          <p:cNvPr id="2" name="Rectangle 1"/>
+          <p:cNvSpPr/>
+          <p:nvPr/>
+        </p:nvSpPr>
+        <p:spPr>
+          <a:xfrm>
+            <a:off x="548640" y="3200400"/>
+            <a:ext cx="2377440" cy="38100"/>
+          </a:xfrm>
+          <a:prstGeom prst="rect">
+            <a:avLst/>
+          </a:prstGeom>
+          <a:solidFill>
+            <a:srgbClr val="F97316"/>
+          </a:solidFill>
+          <a:ln>
+            <a:noFill/>
+          </a:ln>
+        </p:spPr>
+        <p:style>
+          <a:lnRef idx="1">
+            <a:schemeClr val="accent1"/>
+          </a:lnRef>
+          <a:fillRef idx="3">
+            <a:schemeClr val="accent1"/>
+          </a:fillRef>
+          <a:effectRef idx="2">
+            <a:schemeClr val="accent1"/>
+          </a:effectRef>
+          <a:fontRef idx="minor">
+            <a:schemeClr val="lt1"/>
+          </a:fontRef>
+        </p:style>
+        <p:txBody>
+          <a:bodyPr rtlCol="0" anchor="ctr"/>
+          <a:lstStyle/>
+          <a:p>
+            <a:pPr algn="ctr"/>
+          </a:p>
+        </p:txBody>
+      </p:sp>
+      <p:sp>
+        <p:nvSpPr>
+          <p:cNvPr id="3" name="TextBox 2"/>
+          <p:cNvSpPr txBox="1"/>
+          <p:nvPr/>
+        </p:nvSpPr>
+        <p:spPr>
+          <a:xfrm>
+            <a:off x="548640" y="2011680"/>
+            <a:ext cx="10972800" cy="1188720"/>
+          </a:xfrm>
+          <a:prstGeom prst="rect">
+            <a:avLst/>
+          </a:prstGeom>
+          <a:noFill/>
+        </p:spPr>
+        <p:txBody>
+          <a:bodyPr wrap="square">
+            <a:spAutoFit/>
+          </a:bodyPr>
+          <a:lstStyle/>
+          <a:p>
+            <a:r>
+              <a:rPr sz="4000" b="1" i="0">
+                <a:solidFill>
+                  <a:srgbClr val="F1F5F9"/>
+                </a:solidFill>
+                <a:latin typeface="Montserrat"/>
+              </a:rPr>
+              <a:t>Gestão em Movimento</a:t>
+            </a:r>
+          </a:p>
+        </p:txBody>
+      </p:sp>
+      <p:sp>
+        <p:nvSpPr>
+          <p:cNvPr id="4" name="TextBox 3"/>
+          <p:cNvSpPr txBox="1"/>
+          <p:nvPr/>
+        </p:nvSpPr>
+        <p:spPr>
+          <a:xfrm>
+            <a:off x="548640" y="3429000"/>
+            <a:ext cx="10972800" cy="2011680"/>
+          </a:xfrm>
+          <a:prstGeom prst="rect">
+            <a:avLst/>
+          </a:prstGeom>
+          <a:noFill/>
+        </p:spPr>
+        <p:txBody>
+          <a:bodyPr wrap="square">
+            <a:spAutoFit/>
+          </a:bodyPr>
+          <a:lstStyle/>
+          <a:p>
+            <a:r>
+              <a:rPr sz="1800" b="0" i="0">
+                <a:solidFill>
+                  <a:srgbClr val="94A3B8"/>
+                </a:solidFill>
+                <a:latin typeface="Montserrat"/>
+              </a:rPr>
+              <a:t>Do indicador à ação — a gestão da frota inteira num só lugar.</a:t>
+            </a:r>
+          </a:p>
+          <a:p>
+            <a:r>
+              <a:rPr sz="1400" b="1" i="0">
+                <a:solidFill>
+                  <a:srgbClr val="F97316"/>
+                </a:solidFill>
+                <a:latin typeface="Montserrat"/>
+              </a:rPr>
+              <a:t>fortesindicadores-byte.github.io/gestao-em-movimento</a:t>
+            </a:r>
+          </a:p>
+        </p:txBody>
+      </p:sp>
+      <p:sp>
+        <p:nvSpPr>
+          <p:cNvPr id="5" name="TextBox 4"/>
+          <p:cNvSpPr txBox="1"/>
+          <p:nvPr/>
+        </p:nvSpPr>
+        <p:spPr>
+          <a:xfrm>
+            <a:off x="548640" y="6473952"/>
+            <a:ext cx="11064240" cy="320040"/>
+          </a:xfrm>
+          <a:prstGeom prst="rect">
+            <a:avLst/>
+          </a:prstGeom>
+          <a:noFill/>
+        </p:spPr>
+        <p:txBody>
+          <a:bodyPr wrap="square">
+            <a:spAutoFit/>
+          </a:bodyPr>
+          <a:lstStyle/>
+          <a:p>
+            <a:pPr algn="r"/>
+            <a:r>
+              <a:rPr sz="900" b="0" i="0">
+                <a:solidFill>
+                  <a:srgbClr val="64748B"/>
+                </a:solidFill>
+                <a:latin typeface="Montserrat"/>
+              </a:rPr>
+              <a:t>Visão Executiva  ·  13</a:t>
             </a:r>
           </a:p>
         </p:txBody>
@@ -7520,563 +8107,32 @@
                 </a:solidFill>
                 <a:latin typeface="Montserrat"/>
               </a:rPr>
-              <a:t>Modelo operacional — a rotina do mês</a:t>
-            </a:r>
-          </a:p>
-        </p:txBody>
-      </p:sp>
-      <p:sp>
-        <p:nvSpPr>
-          <p:cNvPr id="5" name="Rounded Rectangle 4"/>
-          <p:cNvSpPr/>
-          <p:nvPr/>
-        </p:nvSpPr>
-        <p:spPr>
-          <a:xfrm>
-            <a:off x="548640" y="1828800"/>
-            <a:ext cx="2103120" cy="2103120"/>
-          </a:xfrm>
-          <a:prstGeom prst="roundRect">
-            <a:avLst/>
-          </a:prstGeom>
-          <a:solidFill>
-            <a:srgbClr val="141B26"/>
-          </a:solidFill>
-          <a:ln w="12700">
-            <a:solidFill>
-              <a:srgbClr val="1E2D40"/>
-            </a:solidFill>
-          </a:ln>
-        </p:spPr>
-        <p:style>
-          <a:lnRef idx="1">
-            <a:schemeClr val="accent1"/>
-          </a:lnRef>
-          <a:fillRef idx="3">
-            <a:schemeClr val="accent1"/>
-          </a:fillRef>
-          <a:effectRef idx="2">
-            <a:schemeClr val="accent1"/>
-          </a:effectRef>
-          <a:fontRef idx="minor">
-            <a:schemeClr val="lt1"/>
-          </a:fontRef>
-        </p:style>
-        <p:txBody>
-          <a:bodyPr rtlCol="0" anchor="t" wrap="square" lIns="146304" rIns="128016" tIns="91440" bIns="73152"/>
-          <a:lstStyle/>
-          <a:p>
-            <a:pPr algn="ctr">
-              <a:spcAft>
-                <a:spcPts val="400"/>
-              </a:spcAft>
-            </a:pPr>
-            <a:r>
-              <a:rPr sz="1200" b="1" i="0">
-                <a:solidFill>
-                  <a:srgbClr val="F97316"/>
-                </a:solidFill>
-                <a:latin typeface="Montserrat"/>
-              </a:rPr>
-              <a:t>1 · FECHAMENTO</a:t>
-            </a:r>
-          </a:p>
-          <a:p>
-            <a:pPr>
-              <a:spcAft>
-                <a:spcPts val="200"/>
-              </a:spcAft>
-            </a:pPr>
-            <a:r>
-              <a:rPr sz="1100" b="0" i="0">
+              <a:t>Farol da Frota — a foto de segunda</a:t>
+            </a:r>
+          </a:p>
+          <a:p>
+            <a:r>
+              <a:rPr sz="1200" b="0" i="0">
                 <a:solidFill>
                   <a:srgbClr val="94A3B8"/>
                 </a:solidFill>
                 <a:latin typeface="Montserrat"/>
               </a:rPr>
-              <a:t>Mês fecha; bases oficiais atualizadas (DRE, RPM, termômetro)</a:t>
-            </a:r>
-          </a:p>
-        </p:txBody>
-      </p:sp>
-      <p:sp>
-        <p:nvSpPr>
-          <p:cNvPr id="6" name="Right Arrow 5"/>
-          <p:cNvSpPr/>
-          <p:nvPr/>
-        </p:nvSpPr>
-        <p:spPr>
-          <a:xfrm>
-            <a:off x="2670048" y="2697480"/>
-            <a:ext cx="219456" cy="292608"/>
-          </a:xfrm>
-          <a:prstGeom prst="rightArrow">
-            <a:avLst/>
-          </a:prstGeom>
-          <a:solidFill>
-            <a:srgbClr val="F97316"/>
-          </a:solidFill>
-          <a:ln>
-            <a:noFill/>
-          </a:ln>
-        </p:spPr>
-        <p:style>
-          <a:lnRef idx="1">
-            <a:schemeClr val="accent1"/>
-          </a:lnRef>
-          <a:fillRef idx="3">
-            <a:schemeClr val="accent1"/>
-          </a:fillRef>
-          <a:effectRef idx="2">
-            <a:schemeClr val="accent1"/>
-          </a:effectRef>
-          <a:fontRef idx="minor">
-            <a:schemeClr val="lt1"/>
-          </a:fontRef>
-        </p:style>
-        <p:txBody>
-          <a:bodyPr rtlCol="0" anchor="ctr"/>
-          <a:lstStyle/>
-          <a:p>
-            <a:pPr algn="ctr"/>
-          </a:p>
-        </p:txBody>
-      </p:sp>
-      <p:sp>
-        <p:nvSpPr>
-          <p:cNvPr id="7" name="Rounded Rectangle 6"/>
-          <p:cNvSpPr/>
-          <p:nvPr/>
-        </p:nvSpPr>
-        <p:spPr>
-          <a:xfrm>
-            <a:off x="2807208" y="1828800"/>
-            <a:ext cx="2103120" cy="2103120"/>
-          </a:xfrm>
-          <a:prstGeom prst="roundRect">
-            <a:avLst/>
-          </a:prstGeom>
-          <a:solidFill>
-            <a:srgbClr val="141B26"/>
-          </a:solidFill>
-          <a:ln w="12700">
-            <a:solidFill>
-              <a:srgbClr val="1E2D40"/>
-            </a:solidFill>
-          </a:ln>
-        </p:spPr>
-        <p:style>
-          <a:lnRef idx="1">
-            <a:schemeClr val="accent1"/>
-          </a:lnRef>
-          <a:fillRef idx="3">
-            <a:schemeClr val="accent1"/>
-          </a:fillRef>
-          <a:effectRef idx="2">
-            <a:schemeClr val="accent1"/>
-          </a:effectRef>
-          <a:fontRef idx="minor">
-            <a:schemeClr val="lt1"/>
-          </a:fontRef>
-        </p:style>
-        <p:txBody>
-          <a:bodyPr rtlCol="0" anchor="t" wrap="square" lIns="146304" rIns="128016" tIns="91440" bIns="73152"/>
-          <a:lstStyle/>
-          <a:p>
-            <a:pPr algn="ctr">
-              <a:spcAft>
-                <a:spcPts val="400"/>
-              </a:spcAft>
-            </a:pPr>
-            <a:r>
-              <a:rPr sz="1200" b="1" i="0">
-                <a:solidFill>
-                  <a:srgbClr val="F97316"/>
-                </a:solidFill>
-                <a:latin typeface="Montserrat"/>
-              </a:rPr>
-              <a:t>2 · GERAÇÃO</a:t>
-            </a:r>
-          </a:p>
-          <a:p>
-            <a:pPr>
-              <a:spcAft>
-                <a:spcPts val="200"/>
-              </a:spcAft>
-            </a:pPr>
-            <a:r>
-              <a:rPr sz="1100" b="0" i="0">
-                <a:solidFill>
-                  <a:srgbClr val="94A3B8"/>
-                </a:solidFill>
-                <a:latin typeface="Montserrat"/>
-              </a:rPr>
-              <a:t>Admin clica 2 botões e o sistema cria todos os desvios do mês</a:t>
-            </a:r>
-          </a:p>
-        </p:txBody>
-      </p:sp>
-      <p:sp>
-        <p:nvSpPr>
-          <p:cNvPr id="8" name="Right Arrow 7"/>
-          <p:cNvSpPr/>
-          <p:nvPr/>
-        </p:nvSpPr>
-        <p:spPr>
-          <a:xfrm>
-            <a:off x="4928616" y="2697480"/>
-            <a:ext cx="219456" cy="292608"/>
-          </a:xfrm>
-          <a:prstGeom prst="rightArrow">
-            <a:avLst/>
-          </a:prstGeom>
-          <a:solidFill>
-            <a:srgbClr val="F97316"/>
-          </a:solidFill>
-          <a:ln>
-            <a:noFill/>
-          </a:ln>
-        </p:spPr>
-        <p:style>
-          <a:lnRef idx="1">
-            <a:schemeClr val="accent1"/>
-          </a:lnRef>
-          <a:fillRef idx="3">
-            <a:schemeClr val="accent1"/>
-          </a:fillRef>
-          <a:effectRef idx="2">
-            <a:schemeClr val="accent1"/>
-          </a:effectRef>
-          <a:fontRef idx="minor">
-            <a:schemeClr val="lt1"/>
-          </a:fontRef>
-        </p:style>
-        <p:txBody>
-          <a:bodyPr rtlCol="0" anchor="ctr"/>
-          <a:lstStyle/>
-          <a:p>
-            <a:pPr algn="ctr"/>
-          </a:p>
-        </p:txBody>
-      </p:sp>
-      <p:sp>
-        <p:nvSpPr>
-          <p:cNvPr id="9" name="Rounded Rectangle 8"/>
-          <p:cNvSpPr/>
-          <p:nvPr/>
-        </p:nvSpPr>
-        <p:spPr>
-          <a:xfrm>
-            <a:off x="5065776" y="1828800"/>
-            <a:ext cx="2103120" cy="2103120"/>
-          </a:xfrm>
-          <a:prstGeom prst="roundRect">
-            <a:avLst/>
-          </a:prstGeom>
-          <a:solidFill>
-            <a:srgbClr val="141B26"/>
-          </a:solidFill>
-          <a:ln w="12700">
-            <a:solidFill>
-              <a:srgbClr val="1E2D40"/>
-            </a:solidFill>
-          </a:ln>
-        </p:spPr>
-        <p:style>
-          <a:lnRef idx="1">
-            <a:schemeClr val="accent1"/>
-          </a:lnRef>
-          <a:fillRef idx="3">
-            <a:schemeClr val="accent1"/>
-          </a:fillRef>
-          <a:effectRef idx="2">
-            <a:schemeClr val="accent1"/>
-          </a:effectRef>
-          <a:fontRef idx="minor">
-            <a:schemeClr val="lt1"/>
-          </a:fontRef>
-        </p:style>
-        <p:txBody>
-          <a:bodyPr rtlCol="0" anchor="t" wrap="square" lIns="146304" rIns="128016" tIns="91440" bIns="73152"/>
-          <a:lstStyle/>
-          <a:p>
-            <a:pPr algn="ctr">
-              <a:spcAft>
-                <a:spcPts val="400"/>
-              </a:spcAft>
-            </a:pPr>
-            <a:r>
-              <a:rPr sz="1200" b="1" i="0">
-                <a:solidFill>
-                  <a:srgbClr val="F97316"/>
-                </a:solidFill>
-                <a:latin typeface="Montserrat"/>
-              </a:rPr>
-              <a:t>3 · TRATAMENTO</a:t>
-            </a:r>
-          </a:p>
-          <a:p>
-            <a:pPr>
-              <a:spcAft>
-                <a:spcPts val="200"/>
-              </a:spcAft>
-            </a:pPr>
-            <a:r>
-              <a:rPr sz="1100" b="0" i="0">
-                <a:solidFill>
-                  <a:srgbClr val="94A3B8"/>
-                </a:solidFill>
-                <a:latin typeface="Montserrat"/>
-              </a:rPr>
-              <a:t>Cada unidade preenche causa, ação, responsável e prazo</a:t>
-            </a:r>
-          </a:p>
-        </p:txBody>
-      </p:sp>
-      <p:sp>
-        <p:nvSpPr>
-          <p:cNvPr id="10" name="Right Arrow 9"/>
-          <p:cNvSpPr/>
-          <p:nvPr/>
-        </p:nvSpPr>
-        <p:spPr>
-          <a:xfrm>
-            <a:off x="7187184" y="2697480"/>
-            <a:ext cx="219456" cy="292608"/>
-          </a:xfrm>
-          <a:prstGeom prst="rightArrow">
-            <a:avLst/>
-          </a:prstGeom>
-          <a:solidFill>
-            <a:srgbClr val="F97316"/>
-          </a:solidFill>
-          <a:ln>
-            <a:noFill/>
-          </a:ln>
-        </p:spPr>
-        <p:style>
-          <a:lnRef idx="1">
-            <a:schemeClr val="accent1"/>
-          </a:lnRef>
-          <a:fillRef idx="3">
-            <a:schemeClr val="accent1"/>
-          </a:fillRef>
-          <a:effectRef idx="2">
-            <a:schemeClr val="accent1"/>
-          </a:effectRef>
-          <a:fontRef idx="minor">
-            <a:schemeClr val="lt1"/>
-          </a:fontRef>
-        </p:style>
-        <p:txBody>
-          <a:bodyPr rtlCol="0" anchor="ctr"/>
-          <a:lstStyle/>
-          <a:p>
-            <a:pPr algn="ctr"/>
-          </a:p>
-        </p:txBody>
-      </p:sp>
-      <p:sp>
-        <p:nvSpPr>
-          <p:cNvPr id="11" name="Rounded Rectangle 10"/>
-          <p:cNvSpPr/>
-          <p:nvPr/>
-        </p:nvSpPr>
-        <p:spPr>
-          <a:xfrm>
-            <a:off x="7324344" y="1828800"/>
-            <a:ext cx="2103120" cy="2103120"/>
-          </a:xfrm>
-          <a:prstGeom prst="roundRect">
-            <a:avLst/>
-          </a:prstGeom>
-          <a:solidFill>
-            <a:srgbClr val="141B26"/>
-          </a:solidFill>
-          <a:ln w="12700">
-            <a:solidFill>
-              <a:srgbClr val="1E2D40"/>
-            </a:solidFill>
-          </a:ln>
-        </p:spPr>
-        <p:style>
-          <a:lnRef idx="1">
-            <a:schemeClr val="accent1"/>
-          </a:lnRef>
-          <a:fillRef idx="3">
-            <a:schemeClr val="accent1"/>
-          </a:fillRef>
-          <a:effectRef idx="2">
-            <a:schemeClr val="accent1"/>
-          </a:effectRef>
-          <a:fontRef idx="minor">
-            <a:schemeClr val="lt1"/>
-          </a:fontRef>
-        </p:style>
-        <p:txBody>
-          <a:bodyPr rtlCol="0" anchor="t" wrap="square" lIns="146304" rIns="128016" tIns="91440" bIns="73152"/>
-          <a:lstStyle/>
-          <a:p>
-            <a:pPr algn="ctr">
-              <a:spcAft>
-                <a:spcPts val="400"/>
-              </a:spcAft>
-            </a:pPr>
-            <a:r>
-              <a:rPr sz="1200" b="1" i="0">
-                <a:solidFill>
-                  <a:srgbClr val="F97316"/>
-                </a:solidFill>
-                <a:latin typeface="Montserrat"/>
-              </a:rPr>
-              <a:t>4 · REUNIÃO (MPR)</a:t>
-            </a:r>
-          </a:p>
-          <a:p>
-            <a:pPr>
-              <a:spcAft>
-                <a:spcPts val="200"/>
-              </a:spcAft>
-            </a:pPr>
-            <a:r>
-              <a:rPr sz="1100" b="0" i="0">
-                <a:solidFill>
-                  <a:srgbClr val="94A3B8"/>
-                </a:solidFill>
-                <a:latin typeface="Montserrat"/>
-              </a:rPr>
-              <a:t>Resultados e planos revisados na mesa mensal</a:t>
-            </a:r>
-          </a:p>
-        </p:txBody>
-      </p:sp>
-      <p:sp>
-        <p:nvSpPr>
-          <p:cNvPr id="12" name="Right Arrow 11"/>
-          <p:cNvSpPr/>
-          <p:nvPr/>
-        </p:nvSpPr>
-        <p:spPr>
-          <a:xfrm>
-            <a:off x="9445752" y="2697480"/>
-            <a:ext cx="219456" cy="292608"/>
-          </a:xfrm>
-          <a:prstGeom prst="rightArrow">
-            <a:avLst/>
-          </a:prstGeom>
-          <a:solidFill>
-            <a:srgbClr val="F97316"/>
-          </a:solidFill>
-          <a:ln>
-            <a:noFill/>
-          </a:ln>
-        </p:spPr>
-        <p:style>
-          <a:lnRef idx="1">
-            <a:schemeClr val="accent1"/>
-          </a:lnRef>
-          <a:fillRef idx="3">
-            <a:schemeClr val="accent1"/>
-          </a:fillRef>
-          <a:effectRef idx="2">
-            <a:schemeClr val="accent1"/>
-          </a:effectRef>
-          <a:fontRef idx="minor">
-            <a:schemeClr val="lt1"/>
-          </a:fontRef>
-        </p:style>
-        <p:txBody>
-          <a:bodyPr rtlCol="0" anchor="ctr"/>
-          <a:lstStyle/>
-          <a:p>
-            <a:pPr algn="ctr"/>
-          </a:p>
-        </p:txBody>
-      </p:sp>
-      <p:sp>
-        <p:nvSpPr>
-          <p:cNvPr id="13" name="Rounded Rectangle 12"/>
-          <p:cNvSpPr/>
-          <p:nvPr/>
-        </p:nvSpPr>
-        <p:spPr>
-          <a:xfrm>
-            <a:off x="9582912" y="1828800"/>
-            <a:ext cx="2103120" cy="2103120"/>
-          </a:xfrm>
-          <a:prstGeom prst="roundRect">
-            <a:avLst/>
-          </a:prstGeom>
-          <a:solidFill>
-            <a:srgbClr val="141B26"/>
-          </a:solidFill>
-          <a:ln w="12700">
-            <a:solidFill>
-              <a:srgbClr val="1E2D40"/>
-            </a:solidFill>
-          </a:ln>
-        </p:spPr>
-        <p:style>
-          <a:lnRef idx="1">
-            <a:schemeClr val="accent1"/>
-          </a:lnRef>
-          <a:fillRef idx="3">
-            <a:schemeClr val="accent1"/>
-          </a:fillRef>
-          <a:effectRef idx="2">
-            <a:schemeClr val="accent1"/>
-          </a:effectRef>
-          <a:fontRef idx="minor">
-            <a:schemeClr val="lt1"/>
-          </a:fontRef>
-        </p:style>
-        <p:txBody>
-          <a:bodyPr rtlCol="0" anchor="t" wrap="square" lIns="146304" rIns="128016" tIns="91440" bIns="73152"/>
-          <a:lstStyle/>
-          <a:p>
-            <a:pPr algn="ctr">
-              <a:spcAft>
-                <a:spcPts val="400"/>
-              </a:spcAft>
-            </a:pPr>
-            <a:r>
-              <a:rPr sz="1200" b="1" i="0">
-                <a:solidFill>
-                  <a:srgbClr val="F97316"/>
-                </a:solidFill>
-                <a:latin typeface="Montserrat"/>
-              </a:rPr>
-              <a:t>5 · ACOMPANHAMENTO</a:t>
-            </a:r>
-          </a:p>
-          <a:p>
-            <a:pPr>
-              <a:spcAft>
-                <a:spcPts val="200"/>
-              </a:spcAft>
-            </a:pPr>
-            <a:r>
-              <a:rPr sz="1100" b="0" i="0">
-                <a:solidFill>
-                  <a:srgbClr val="94A3B8"/>
-                </a:solidFill>
-                <a:latin typeface="Montserrat"/>
-              </a:rPr>
-              <a:t>Aderência, kanban e termômetro até o próximo ciclo</a:t>
-            </a:r>
-          </a:p>
-        </p:txBody>
-      </p:sp>
-      <p:sp>
-        <p:nvSpPr>
-          <p:cNvPr id="14" name="TextBox 13"/>
+              <a:t>Cada gestor recebe seu retrato semanal por e-mail</a:t>
+            </a:r>
+          </a:p>
+        </p:txBody>
+      </p:sp>
+      <p:sp>
+        <p:nvSpPr>
+          <p:cNvPr id="5" name="TextBox 4"/>
           <p:cNvSpPr txBox="1"/>
           <p:nvPr/>
         </p:nvSpPr>
         <p:spPr>
           <a:xfrm>
-            <a:off x="548640" y="4389120"/>
-            <a:ext cx="11064240" cy="1280160"/>
+            <a:off x="548640" y="1417320"/>
+            <a:ext cx="11064240" cy="5120640"/>
           </a:xfrm>
           <a:prstGeom prst="rect">
             <a:avLst/>
@@ -8089,21 +8145,110 @@
           </a:bodyPr>
           <a:lstStyle/>
           <a:p>
-            <a:r>
-              <a:rPr sz="1400" b="1" i="0">
-                <a:solidFill>
-                  <a:srgbClr val="94A3B8"/>
-                </a:solidFill>
-                <a:latin typeface="Montserrat"/>
-              </a:rPr>
-              <a:t>Sem carga manual de dados, sem consolidação em Excel: o portal lê as fontes e conduz o processo.</a:t>
-            </a:r>
-          </a:p>
-        </p:txBody>
-      </p:sp>
-      <p:sp>
-        <p:nvSpPr>
-          <p:cNvPr id="15" name="TextBox 14"/>
+            <a:pPr>
+              <a:spcAft>
+                <a:spcPts val="700"/>
+              </a:spcAft>
+            </a:pPr>
+            <a:r>
+              <a:rPr sz="1500" b="1" i="0">
+                <a:solidFill>
+                  <a:srgbClr val="F97316"/>
+                </a:solidFill>
+                <a:latin typeface="Montserrat"/>
+              </a:rPr>
+              <a:t>▪  </a:t>
+            </a:r>
+            <a:r>
+              <a:rPr sz="1500" b="0" i="0">
+                <a:solidFill>
+                  <a:srgbClr val="F1F5F9"/>
+                </a:solidFill>
+                <a:latin typeface="Montserrat"/>
+              </a:rPr>
+              <a:t>Um raio-x semanal da frota, por unidade: custos, stress test, CIFV, preventivas, alinhamento, OSs, disponibilidade e pneus.</a:t>
+            </a:r>
+          </a:p>
+          <a:p>
+            <a:pPr>
+              <a:spcAft>
+                <a:spcPts val="700"/>
+              </a:spcAft>
+            </a:pPr>
+            <a:r>
+              <a:rPr sz="1500" b="1" i="0">
+                <a:solidFill>
+                  <a:srgbClr val="F97316"/>
+                </a:solidFill>
+                <a:latin typeface="Montserrat"/>
+              </a:rPr>
+              <a:t>▪  </a:t>
+            </a:r>
+            <a:r>
+              <a:rPr sz="1500" b="0" i="0">
+                <a:solidFill>
+                  <a:srgbClr val="F1F5F9"/>
+                </a:solidFill>
+                <a:latin typeface="Montserrat"/>
+              </a:rPr>
+              <a:t>A foto é tirada toda segunda às 14h — o gestor recebe no e-mail, sem precisar entrar no portal.</a:t>
+            </a:r>
+          </a:p>
+          <a:p>
+            <a:pPr>
+              <a:spcAft>
+                <a:spcPts val="700"/>
+              </a:spcAft>
+            </a:pPr>
+            <a:r>
+              <a:rPr sz="1500" b="1" i="0">
+                <a:solidFill>
+                  <a:srgbClr val="F97316"/>
+                </a:solidFill>
+                <a:latin typeface="Montserrat"/>
+              </a:rPr>
+              <a:t>▪  </a:t>
+            </a:r>
+            <a:r>
+              <a:rPr sz="1500" b="0" i="0">
+                <a:solidFill>
+                  <a:srgbClr val="F1F5F9"/>
+                </a:solidFill>
+                <a:latin typeface="Montserrat"/>
+              </a:rPr>
+              <a:t>Visão geral com Ranking das Unidades e Resumo Executivo: o que está bom, o que é crítico e os próximos passos.</a:t>
+            </a:r>
+          </a:p>
+          <a:p>
+            <a:pPr>
+              <a:spcAft>
+                <a:spcPts val="700"/>
+              </a:spcAft>
+            </a:pPr>
+            <a:r>
+              <a:rPr sz="1500" b="1" i="0">
+                <a:solidFill>
+                  <a:srgbClr val="F97316"/>
+                </a:solidFill>
+                <a:latin typeface="Montserrat"/>
+              </a:rPr>
+              <a:t>▪  </a:t>
+            </a:r>
+            <a:r>
+              <a:rPr sz="1500" b="0" i="0">
+                <a:solidFill>
+                  <a:srgbClr val="F1F5F9"/>
+                </a:solidFill>
+                <a:latin typeface="Montserrat"/>
+              </a:rPr>
+              <a:t>Liberação simples: no Gerenciar Acessos marca-se de quais unidades cada pessoa recebe o Farol.</a:t>
+            </a:r>
+          </a:p>
+        </p:txBody>
+      </p:sp>
+      <p:sp>
+        <p:nvSpPr>
+          <p:cNvPr id="6" name="TextBox 5"/>
           <p:cNvSpPr txBox="1"/>
           <p:nvPr/>
         </p:nvSpPr>
@@ -8288,7 +8433,7 @@
                 </a:solidFill>
                 <a:latin typeface="Montserrat"/>
               </a:rPr>
-              <a:t>Benefícios</a:t>
+              <a:t>Modelo operacional — a rotina do mês</a:t>
             </a:r>
           </a:p>
         </p:txBody>
@@ -8301,8 +8446,8 @@
         </p:nvSpPr>
         <p:spPr>
           <a:xfrm>
-            <a:off x="548640" y="1554480"/>
-            <a:ext cx="5394960" cy="1417320"/>
+            <a:off x="548640" y="1828800"/>
+            <a:ext cx="2103120" cy="2103120"/>
           </a:xfrm>
           <a:prstGeom prst="roundRect">
             <a:avLst/>
@@ -8340,13 +8485,13 @@
               </a:spcAft>
             </a:pPr>
             <a:r>
-              <a:rPr sz="1300" b="1" i="0">
-                <a:solidFill>
-                  <a:srgbClr val="3BB33B"/>
-                </a:solidFill>
-                <a:latin typeface="Montserrat"/>
-              </a:rPr>
-              <a:t>CUSTO ≈ ZERO DE INFRAESTRUTURA</a:t>
+              <a:rPr sz="1200" b="1" i="0">
+                <a:solidFill>
+                  <a:srgbClr val="F97316"/>
+                </a:solidFill>
+                <a:latin typeface="Montserrat"/>
+              </a:rPr>
+              <a:t>1 · FECHAMENTO</a:t>
             </a:r>
           </a:p>
           <a:p>
@@ -8362,37 +8507,64 @@
                 </a:solidFill>
                 <a:latin typeface="Montserrat"/>
               </a:rPr>
-              <a:t>Hospedagem e automações em camadas gratuitas;</a:t>
-            </a:r>
-          </a:p>
-          <a:p>
-            <a:pPr>
-              <a:spcAft>
-                <a:spcPts val="200"/>
-              </a:spcAft>
-            </a:pPr>
-            <a:r>
-              <a:rPr sz="1100" b="0" i="0">
-                <a:solidFill>
-                  <a:srgbClr val="94A3B8"/>
-                </a:solidFill>
-                <a:latin typeface="Montserrat"/>
-              </a:rPr>
-              <a:t>sem licença por usuário (vs. ferramenta paga de BI)</a:t>
-            </a:r>
-          </a:p>
-        </p:txBody>
-      </p:sp>
-      <p:sp>
-        <p:nvSpPr>
-          <p:cNvPr id="6" name="Rounded Rectangle 5"/>
+              <a:t>Mês fecha; bases oficiais atualizadas (DRE, RPM, termômetro)</a:t>
+            </a:r>
+          </a:p>
+        </p:txBody>
+      </p:sp>
+      <p:sp>
+        <p:nvSpPr>
+          <p:cNvPr id="6" name="Right Arrow 5"/>
           <p:cNvSpPr/>
           <p:nvPr/>
         </p:nvSpPr>
         <p:spPr>
           <a:xfrm>
-            <a:off x="6217920" y="1554480"/>
-            <a:ext cx="5394960" cy="1417320"/>
+            <a:off x="2670048" y="2697480"/>
+            <a:ext cx="219456" cy="292608"/>
+          </a:xfrm>
+          <a:prstGeom prst="rightArrow">
+            <a:avLst/>
+          </a:prstGeom>
+          <a:solidFill>
+            <a:srgbClr val="F97316"/>
+          </a:solidFill>
+          <a:ln>
+            <a:noFill/>
+          </a:ln>
+        </p:spPr>
+        <p:style>
+          <a:lnRef idx="1">
+            <a:schemeClr val="accent1"/>
+          </a:lnRef>
+          <a:fillRef idx="3">
+            <a:schemeClr val="accent1"/>
+          </a:fillRef>
+          <a:effectRef idx="2">
+            <a:schemeClr val="accent1"/>
+          </a:effectRef>
+          <a:fontRef idx="minor">
+            <a:schemeClr val="lt1"/>
+          </a:fontRef>
+        </p:style>
+        <p:txBody>
+          <a:bodyPr rtlCol="0" anchor="ctr"/>
+          <a:lstStyle/>
+          <a:p>
+            <a:pPr algn="ctr"/>
+          </a:p>
+        </p:txBody>
+      </p:sp>
+      <p:sp>
+        <p:nvSpPr>
+          <p:cNvPr id="7" name="Rounded Rectangle 6"/>
+          <p:cNvSpPr/>
+          <p:nvPr/>
+        </p:nvSpPr>
+        <p:spPr>
+          <a:xfrm>
+            <a:off x="2807208" y="1828800"/>
+            <a:ext cx="2103120" cy="2103120"/>
           </a:xfrm>
           <a:prstGeom prst="roundRect">
             <a:avLst/>
@@ -8430,13 +8602,13 @@
               </a:spcAft>
             </a:pPr>
             <a:r>
-              <a:rPr sz="1300" b="1" i="0">
-                <a:solidFill>
-                  <a:srgbClr val="3BB33B"/>
-                </a:solidFill>
-                <a:latin typeface="Montserrat"/>
-              </a:rPr>
-              <a:t>FONTE ÚNICA DA VERDADE</a:t>
+              <a:rPr sz="1200" b="1" i="0">
+                <a:solidFill>
+                  <a:srgbClr val="F97316"/>
+                </a:solidFill>
+                <a:latin typeface="Montserrat"/>
+              </a:rPr>
+              <a:t>2 · GERAÇÃO</a:t>
             </a:r>
           </a:p>
           <a:p>
@@ -8452,37 +8624,64 @@
                 </a:solidFill>
                 <a:latin typeface="Montserrat"/>
               </a:rPr>
-              <a:t>Mesmo número em todos os painéis;</a:t>
-            </a:r>
-          </a:p>
-          <a:p>
-            <a:pPr>
-              <a:spcAft>
-                <a:spcPts val="200"/>
-              </a:spcAft>
-            </a:pPr>
-            <a:r>
-              <a:rPr sz="1100" b="0" i="0">
-                <a:solidFill>
-                  <a:srgbClr val="94A3B8"/>
-                </a:solidFill>
-                <a:latin typeface="Montserrat"/>
-              </a:rPr>
-              <a:t>planos de ação centralizados e auditáveis na nuvem</a:t>
-            </a:r>
-          </a:p>
-        </p:txBody>
-      </p:sp>
-      <p:sp>
-        <p:nvSpPr>
-          <p:cNvPr id="7" name="Rounded Rectangle 6"/>
+              <a:t>Admin clica 2 botões e o sistema cria todos os desvios do mês</a:t>
+            </a:r>
+          </a:p>
+        </p:txBody>
+      </p:sp>
+      <p:sp>
+        <p:nvSpPr>
+          <p:cNvPr id="8" name="Right Arrow 7"/>
           <p:cNvSpPr/>
           <p:nvPr/>
         </p:nvSpPr>
         <p:spPr>
           <a:xfrm>
-            <a:off x="548640" y="3154680"/>
-            <a:ext cx="5394960" cy="1417320"/>
+            <a:off x="4928616" y="2697480"/>
+            <a:ext cx="219456" cy="292608"/>
+          </a:xfrm>
+          <a:prstGeom prst="rightArrow">
+            <a:avLst/>
+          </a:prstGeom>
+          <a:solidFill>
+            <a:srgbClr val="F97316"/>
+          </a:solidFill>
+          <a:ln>
+            <a:noFill/>
+          </a:ln>
+        </p:spPr>
+        <p:style>
+          <a:lnRef idx="1">
+            <a:schemeClr val="accent1"/>
+          </a:lnRef>
+          <a:fillRef idx="3">
+            <a:schemeClr val="accent1"/>
+          </a:fillRef>
+          <a:effectRef idx="2">
+            <a:schemeClr val="accent1"/>
+          </a:effectRef>
+          <a:fontRef idx="minor">
+            <a:schemeClr val="lt1"/>
+          </a:fontRef>
+        </p:style>
+        <p:txBody>
+          <a:bodyPr rtlCol="0" anchor="ctr"/>
+          <a:lstStyle/>
+          <a:p>
+            <a:pPr algn="ctr"/>
+          </a:p>
+        </p:txBody>
+      </p:sp>
+      <p:sp>
+        <p:nvSpPr>
+          <p:cNvPr id="9" name="Rounded Rectangle 8"/>
+          <p:cNvSpPr/>
+          <p:nvPr/>
+        </p:nvSpPr>
+        <p:spPr>
+          <a:xfrm>
+            <a:off x="5065776" y="1828800"/>
+            <a:ext cx="2103120" cy="2103120"/>
           </a:xfrm>
           <a:prstGeom prst="roundRect">
             <a:avLst/>
@@ -8520,13 +8719,13 @@
               </a:spcAft>
             </a:pPr>
             <a:r>
-              <a:rPr sz="1300" b="1" i="0">
-                <a:solidFill>
-                  <a:srgbClr val="3BB33B"/>
-                </a:solidFill>
-                <a:latin typeface="Montserrat"/>
-              </a:rPr>
-              <a:t>GOVERNANÇA E ACCOUNTABILITY</a:t>
+              <a:rPr sz="1200" b="1" i="0">
+                <a:solidFill>
+                  <a:srgbClr val="F97316"/>
+                </a:solidFill>
+                <a:latin typeface="Montserrat"/>
+              </a:rPr>
+              <a:t>3 · TRATAMENTO</a:t>
             </a:r>
           </a:p>
           <a:p>
@@ -8542,37 +8741,64 @@
                 </a:solidFill>
                 <a:latin typeface="Montserrat"/>
               </a:rPr>
-              <a:t>Cada desvio com dono, prazo e status;</a:t>
-            </a:r>
-          </a:p>
-          <a:p>
-            <a:pPr>
-              <a:spcAft>
-                <a:spcPts val="200"/>
-              </a:spcAft>
-            </a:pPr>
-            <a:r>
-              <a:rPr sz="1100" b="0" i="0">
-                <a:solidFill>
-                  <a:srgbClr val="94A3B8"/>
-                </a:solidFill>
-                <a:latin typeface="Montserrat"/>
-              </a:rPr>
-              <a:t>aderência medida; ranking dá consequência</a:t>
-            </a:r>
-          </a:p>
-        </p:txBody>
-      </p:sp>
-      <p:sp>
-        <p:nvSpPr>
-          <p:cNvPr id="8" name="Rounded Rectangle 7"/>
+              <a:t>Cada unidade preenche causa, ação, responsável e prazo</a:t>
+            </a:r>
+          </a:p>
+        </p:txBody>
+      </p:sp>
+      <p:sp>
+        <p:nvSpPr>
+          <p:cNvPr id="10" name="Right Arrow 9"/>
           <p:cNvSpPr/>
           <p:nvPr/>
         </p:nvSpPr>
         <p:spPr>
           <a:xfrm>
-            <a:off x="6217920" y="3154680"/>
-            <a:ext cx="5394960" cy="1417320"/>
+            <a:off x="7187184" y="2697480"/>
+            <a:ext cx="219456" cy="292608"/>
+          </a:xfrm>
+          <a:prstGeom prst="rightArrow">
+            <a:avLst/>
+          </a:prstGeom>
+          <a:solidFill>
+            <a:srgbClr val="F97316"/>
+          </a:solidFill>
+          <a:ln>
+            <a:noFill/>
+          </a:ln>
+        </p:spPr>
+        <p:style>
+          <a:lnRef idx="1">
+            <a:schemeClr val="accent1"/>
+          </a:lnRef>
+          <a:fillRef idx="3">
+            <a:schemeClr val="accent1"/>
+          </a:fillRef>
+          <a:effectRef idx="2">
+            <a:schemeClr val="accent1"/>
+          </a:effectRef>
+          <a:fontRef idx="minor">
+            <a:schemeClr val="lt1"/>
+          </a:fontRef>
+        </p:style>
+        <p:txBody>
+          <a:bodyPr rtlCol="0" anchor="ctr"/>
+          <a:lstStyle/>
+          <a:p>
+            <a:pPr algn="ctr"/>
+          </a:p>
+        </p:txBody>
+      </p:sp>
+      <p:sp>
+        <p:nvSpPr>
+          <p:cNvPr id="11" name="Rounded Rectangle 10"/>
+          <p:cNvSpPr/>
+          <p:nvPr/>
+        </p:nvSpPr>
+        <p:spPr>
+          <a:xfrm>
+            <a:off x="7324344" y="1828800"/>
+            <a:ext cx="2103120" cy="2103120"/>
           </a:xfrm>
           <a:prstGeom prst="roundRect">
             <a:avLst/>
@@ -8610,13 +8836,13 @@
               </a:spcAft>
             </a:pPr>
             <a:r>
-              <a:rPr sz="1300" b="1" i="0">
-                <a:solidFill>
-                  <a:srgbClr val="3BB33B"/>
-                </a:solidFill>
-                <a:latin typeface="Montserrat"/>
-              </a:rPr>
-              <a:t>AGILIDADE</a:t>
+              <a:rPr sz="1200" b="1" i="0">
+                <a:solidFill>
+                  <a:srgbClr val="F97316"/>
+                </a:solidFill>
+                <a:latin typeface="Montserrat"/>
+              </a:rPr>
+              <a:t>4 · REUNIÃO (MPR)</a:t>
             </a:r>
           </a:p>
           <a:p>
@@ -8632,7 +8858,108 @@
                 </a:solidFill>
                 <a:latin typeface="Montserrat"/>
               </a:rPr>
-              <a:t>Dados ao abrir a página (sem espera de carga);</a:t>
+              <a:t>Resultados e planos revisados na mesa mensal</a:t>
+            </a:r>
+          </a:p>
+        </p:txBody>
+      </p:sp>
+      <p:sp>
+        <p:nvSpPr>
+          <p:cNvPr id="12" name="Right Arrow 11"/>
+          <p:cNvSpPr/>
+          <p:nvPr/>
+        </p:nvSpPr>
+        <p:spPr>
+          <a:xfrm>
+            <a:off x="9445752" y="2697480"/>
+            <a:ext cx="219456" cy="292608"/>
+          </a:xfrm>
+          <a:prstGeom prst="rightArrow">
+            <a:avLst/>
+          </a:prstGeom>
+          <a:solidFill>
+            <a:srgbClr val="F97316"/>
+          </a:solidFill>
+          <a:ln>
+            <a:noFill/>
+          </a:ln>
+        </p:spPr>
+        <p:style>
+          <a:lnRef idx="1">
+            <a:schemeClr val="accent1"/>
+          </a:lnRef>
+          <a:fillRef idx="3">
+            <a:schemeClr val="accent1"/>
+          </a:fillRef>
+          <a:effectRef idx="2">
+            <a:schemeClr val="accent1"/>
+          </a:effectRef>
+          <a:fontRef idx="minor">
+            <a:schemeClr val="lt1"/>
+          </a:fontRef>
+        </p:style>
+        <p:txBody>
+          <a:bodyPr rtlCol="0" anchor="ctr"/>
+          <a:lstStyle/>
+          <a:p>
+            <a:pPr algn="ctr"/>
+          </a:p>
+        </p:txBody>
+      </p:sp>
+      <p:sp>
+        <p:nvSpPr>
+          <p:cNvPr id="13" name="Rounded Rectangle 12"/>
+          <p:cNvSpPr/>
+          <p:nvPr/>
+        </p:nvSpPr>
+        <p:spPr>
+          <a:xfrm>
+            <a:off x="9582912" y="1828800"/>
+            <a:ext cx="2103120" cy="2103120"/>
+          </a:xfrm>
+          <a:prstGeom prst="roundRect">
+            <a:avLst/>
+          </a:prstGeom>
+          <a:solidFill>
+            <a:srgbClr val="141B26"/>
+          </a:solidFill>
+          <a:ln w="12700">
+            <a:solidFill>
+              <a:srgbClr val="1E2D40"/>
+            </a:solidFill>
+          </a:ln>
+        </p:spPr>
+        <p:style>
+          <a:lnRef idx="1">
+            <a:schemeClr val="accent1"/>
+          </a:lnRef>
+          <a:fillRef idx="3">
+            <a:schemeClr val="accent1"/>
+          </a:fillRef>
+          <a:effectRef idx="2">
+            <a:schemeClr val="accent1"/>
+          </a:effectRef>
+          <a:fontRef idx="minor">
+            <a:schemeClr val="lt1"/>
+          </a:fontRef>
+        </p:style>
+        <p:txBody>
+          <a:bodyPr rtlCol="0" anchor="t" wrap="square" lIns="146304" rIns="128016" tIns="91440" bIns="73152"/>
+          <a:lstStyle/>
+          <a:p>
+            <a:pPr algn="ctr">
+              <a:spcAft>
+                <a:spcPts val="400"/>
+              </a:spcAft>
+            </a:pPr>
+            <a:r>
+              <a:rPr sz="1200" b="1" i="0">
+                <a:solidFill>
+                  <a:srgbClr val="F97316"/>
+                </a:solidFill>
+                <a:latin typeface="Montserrat"/>
+              </a:rPr>
+              <a:t>5 · ACOMPANHAMENTO</a:t>
             </a:r>
           </a:p>
           <a:p>
@@ -8648,21 +8975,21 @@
                 </a:solidFill>
                 <a:latin typeface="Montserrat"/>
               </a:rPr>
-              <a:t>novos painéis em dias, sem depender de fornecedor</a:t>
-            </a:r>
-          </a:p>
-        </p:txBody>
-      </p:sp>
-      <p:sp>
-        <p:nvSpPr>
-          <p:cNvPr id="9" name="TextBox 8"/>
+              <a:t>Aderência, kanban e termômetro até o próximo ciclo</a:t>
+            </a:r>
+          </a:p>
+        </p:txBody>
+      </p:sp>
+      <p:sp>
+        <p:nvSpPr>
+          <p:cNvPr id="14" name="TextBox 13"/>
           <p:cNvSpPr txBox="1"/>
           <p:nvPr/>
         </p:nvSpPr>
         <p:spPr>
           <a:xfrm>
-            <a:off x="548640" y="4892040"/>
-            <a:ext cx="11064240" cy="1097280"/>
+            <a:off x="548640" y="4389120"/>
+            <a:ext cx="11064240" cy="1280160"/>
           </a:xfrm>
           <a:prstGeom prst="rect">
             <a:avLst/>
@@ -8678,18 +9005,18 @@
             <a:r>
               <a:rPr sz="1400" b="1" i="0">
                 <a:solidFill>
-                  <a:srgbClr val="F97316"/>
-                </a:solidFill>
-                <a:latin typeface="Montserrat"/>
-              </a:rPr>
-              <a:t>Substituição completa do Looker Studio concluída — com mais funcionalidades (preenchimento, kanban, travas, perfis).</a:t>
-            </a:r>
-          </a:p>
-        </p:txBody>
-      </p:sp>
-      <p:sp>
-        <p:nvSpPr>
-          <p:cNvPr id="10" name="TextBox 9"/>
+                  <a:srgbClr val="94A3B8"/>
+                </a:solidFill>
+                <a:latin typeface="Montserrat"/>
+              </a:rPr>
+              <a:t>Sem carga manual de dados, sem consolidação em Excel: o portal lê as fontes e conduz o processo.</a:t>
+            </a:r>
+          </a:p>
+        </p:txBody>
+      </p:sp>
+      <p:sp>
+        <p:nvSpPr>
+          <p:cNvPr id="15" name="TextBox 14"/>
           <p:cNvSpPr txBox="1"/>
           <p:nvPr/>
         </p:nvSpPr>

</xml_diff>